<commit_message>
docs: remove Project Wise Progress section from DRI Dashboard Overview deck
Trims the deck to the two features still being covered (Daily Progress
Report, Drawing Requests), renumbering both sections and the closing
slide accordingly.
</commit_message>
<xml_diff>
--- a/DRI_Dashboard_Overview.pptx
+++ b/DRI_Dashboard_Overview.pptx
@@ -17,11 +17,9 @@
     <p:sldId id="265" r:id="rId11"/>
     <p:sldId id="266" r:id="rId12"/>
     <p:sldId id="267" r:id="rId13"/>
-    <p:sldId id="268" r:id="rId14"/>
-    <p:sldId id="269" r:id="rId15"/>
   </p:sldIdLst>
   <p:notesMasterIdLst>
-    <p:notesMasterId r:id="rId16"/>
+    <p:notesMasterId r:id="rId14"/>
   </p:notesMasterIdLst>
   <p:sldSz cx="12191695" cy="6858000"/>
   <p:notesSz cx="6858000" cy="12191695"/>
@@ -803,182 +801,6 @@
             <a:fld id="{F7021451-1387-4CA6-816F-3879F97B5CBC}" type="slidenum">
               <a:rPr lang="en-US"/>
               <a:t>12</a:t>
-            </a:fld>
-            <a:endParaRPr lang="en-US"/>
-          </a:p>
-        </p:txBody>
-      </p:sp>
-    </p:spTree>
-    <p:extLst>
-      <p:ext uri="{BB962C8B-B14F-4D97-AF65-F5344CB8AC3E}">
-        <p14:creationId xmlns:p14="http://schemas.microsoft.com/office/powerpoint/2010/main" val="1024086991"/>
-      </p:ext>
-    </p:extLst>
-  </p:cSld>
-  <p:clrMapOvr>
-    <a:masterClrMapping/>
-  </p:clrMapOvr>
-</p:notes>
-</file>
-
-<file path=ppt/notesSlides/notesSlide13.xml><?xml version="1.0" encoding="utf-8"?>
-<p:notes xmlns:a="http://schemas.openxmlformats.org/drawingml/2006/main" xmlns:r="http://schemas.openxmlformats.org/officeDocument/2006/relationships" xmlns:p="http://schemas.openxmlformats.org/presentationml/2006/main">
-  <p:cSld>
-    <p:spTree>
-      <p:nvGrpSpPr>
-        <p:cNvPr id="1" name=""/>
-        <p:cNvGrpSpPr/>
-        <p:nvPr/>
-      </p:nvGrpSpPr>
-      <p:grpSpPr>
-        <a:xfrm>
-          <a:off x="0" y="0"/>
-          <a:ext cx="0" cy="0"/>
-          <a:chOff x="0" y="0"/>
-          <a:chExt cx="0" cy="0"/>
-        </a:xfrm>
-      </p:grpSpPr>
-      <p:sp>
-        <p:nvSpPr>
-          <p:cNvPr id="2" name="Slide Image Placeholder 1"/>
-          <p:cNvSpPr>
-            <a:spLocks noGrp="1" noRot="1" noChangeAspect="1"/>
-          </p:cNvSpPr>
-          <p:nvPr>
-            <p:ph type="sldImg"/>
-          </p:nvPr>
-        </p:nvSpPr>
-        <p:spPr/>
-      </p:sp>
-      <p:sp>
-        <p:nvSpPr>
-          <p:cNvPr id="3" name="Notes Placeholder 2"/>
-          <p:cNvSpPr>
-            <a:spLocks noGrp="1"/>
-          </p:cNvSpPr>
-          <p:nvPr>
-            <p:ph type="body" idx="1"/>
-          </p:nvPr>
-        </p:nvSpPr>
-        <p:spPr/>
-        <p:txBody>
-          <a:bodyPr/>
-          <a:lstStyle/>
-          <a:p>
-            <a:r>
-              <a:rPr lang="en-US" dirty="0"/>
-              <a:t/>
-            </a:r>
-            <a:endParaRPr lang="en-US" dirty="0"/>
-          </a:p>
-        </p:txBody>
-      </p:sp>
-      <p:sp>
-        <p:nvSpPr>
-          <p:cNvPr id="4" name="Slide Number Placeholder 3"/>
-          <p:cNvSpPr>
-            <a:spLocks noGrp="1"/>
-          </p:cNvSpPr>
-          <p:nvPr>
-            <p:ph type="sldNum" sz="quarter" idx="10"/>
-          </p:nvPr>
-        </p:nvSpPr>
-        <p:spPr/>
-        <p:txBody>
-          <a:bodyPr/>
-          <a:lstStyle/>
-          <a:p>
-            <a:fld id="{F7021451-1387-4CA6-816F-3879F97B5CBC}" type="slidenum">
-              <a:rPr lang="en-US"/>
-              <a:t>13</a:t>
-            </a:fld>
-            <a:endParaRPr lang="en-US"/>
-          </a:p>
-        </p:txBody>
-      </p:sp>
-    </p:spTree>
-    <p:extLst>
-      <p:ext uri="{BB962C8B-B14F-4D97-AF65-F5344CB8AC3E}">
-        <p14:creationId xmlns:p14="http://schemas.microsoft.com/office/powerpoint/2010/main" val="1024086991"/>
-      </p:ext>
-    </p:extLst>
-  </p:cSld>
-  <p:clrMapOvr>
-    <a:masterClrMapping/>
-  </p:clrMapOvr>
-</p:notes>
-</file>
-
-<file path=ppt/notesSlides/notesSlide14.xml><?xml version="1.0" encoding="utf-8"?>
-<p:notes xmlns:a="http://schemas.openxmlformats.org/drawingml/2006/main" xmlns:r="http://schemas.openxmlformats.org/officeDocument/2006/relationships" xmlns:p="http://schemas.openxmlformats.org/presentationml/2006/main">
-  <p:cSld>
-    <p:spTree>
-      <p:nvGrpSpPr>
-        <p:cNvPr id="1" name=""/>
-        <p:cNvGrpSpPr/>
-        <p:nvPr/>
-      </p:nvGrpSpPr>
-      <p:grpSpPr>
-        <a:xfrm>
-          <a:off x="0" y="0"/>
-          <a:ext cx="0" cy="0"/>
-          <a:chOff x="0" y="0"/>
-          <a:chExt cx="0" cy="0"/>
-        </a:xfrm>
-      </p:grpSpPr>
-      <p:sp>
-        <p:nvSpPr>
-          <p:cNvPr id="2" name="Slide Image Placeholder 1"/>
-          <p:cNvSpPr>
-            <a:spLocks noGrp="1" noRot="1" noChangeAspect="1"/>
-          </p:cNvSpPr>
-          <p:nvPr>
-            <p:ph type="sldImg"/>
-          </p:nvPr>
-        </p:nvSpPr>
-        <p:spPr/>
-      </p:sp>
-      <p:sp>
-        <p:nvSpPr>
-          <p:cNvPr id="3" name="Notes Placeholder 2"/>
-          <p:cNvSpPr>
-            <a:spLocks noGrp="1"/>
-          </p:cNvSpPr>
-          <p:nvPr>
-            <p:ph type="body" idx="1"/>
-          </p:nvPr>
-        </p:nvSpPr>
-        <p:spPr/>
-        <p:txBody>
-          <a:bodyPr/>
-          <a:lstStyle/>
-          <a:p>
-            <a:r>
-              <a:rPr lang="en-US" dirty="0"/>
-              <a:t/>
-            </a:r>
-            <a:endParaRPr lang="en-US" dirty="0"/>
-          </a:p>
-        </p:txBody>
-      </p:sp>
-      <p:sp>
-        <p:nvSpPr>
-          <p:cNvPr id="4" name="Slide Number Placeholder 3"/>
-          <p:cNvSpPr>
-            <a:spLocks noGrp="1"/>
-          </p:cNvSpPr>
-          <p:nvPr>
-            <p:ph type="sldNum" sz="quarter" idx="10"/>
-          </p:nvPr>
-        </p:nvSpPr>
-        <p:spPr/>
-        <p:txBody>
-          <a:bodyPr/>
-          <a:lstStyle/>
-          <a:p>
-            <a:fld id="{F7021451-1387-4CA6-816F-3879F97B5CBC}" type="slidenum">
-              <a:rPr lang="en-US"/>
-              <a:t>14</a:t>
             </a:fld>
             <a:endParaRPr lang="en-US"/>
           </a:p>
@@ -2263,7 +2085,7 @@
                 <a:ea typeface="Segoe UI" pitchFamily="34" charset="-122"/>
                 <a:cs typeface="Segoe UI" pitchFamily="34" charset="-120"/>
               </a:rPr>
-              <a:t>How Site DRIs track daily work, log progress, and request drawings — end to end.</a:t>
+              <a:t>How Site DRIs log daily reports and request drawings — end to end.</a:t>
             </a:r>
             <a:endParaRPr lang="en-US" sz="1500" dirty="0"/>
           </a:p>
@@ -2286,7 +2108,7 @@
             </a:avLst>
           </a:prstGeom>
           <a:solidFill>
-            <a:srgbClr val="FF7A00"/>
+            <a:srgbClr val="4F46E5"/>
           </a:solidFill>
           <a:ln/>
         </p:spPr>
@@ -2324,7 +2146,7 @@
                 <a:ea typeface="Segoe UI" pitchFamily="34" charset="-122"/>
                 <a:cs typeface="Segoe UI" pitchFamily="34" charset="-120"/>
               </a:rPr>
-              <a:t>Project Wise Progress</a:t>
+              <a:t>Daily Progress Report</a:t>
             </a:r>
             <a:endParaRPr lang="en-US" sz="1250" dirty="0"/>
           </a:p>
@@ -2339,7 +2161,7 @@
         <p:spPr>
           <a:xfrm>
             <a:off x="3552444" y="5029200"/>
-            <a:ext cx="2528316" cy="457200"/>
+            <a:ext cx="2002536" cy="457200"/>
           </a:xfrm>
           <a:prstGeom prst="roundRect">
             <a:avLst>
@@ -2347,67 +2169,6 @@
             </a:avLst>
           </a:prstGeom>
           <a:solidFill>
-            <a:srgbClr val="4F46E5"/>
-          </a:solidFill>
-          <a:ln/>
-        </p:spPr>
-      </p:sp>
-      <p:sp>
-        <p:nvSpPr>
-          <p:cNvPr id="12" name="Text 10"/>
-          <p:cNvSpPr/>
-          <p:nvPr/>
-        </p:nvSpPr>
-        <p:spPr>
-          <a:xfrm>
-            <a:off x="3552444" y="5029200"/>
-            <a:ext cx="2528316" cy="457200"/>
-          </a:xfrm>
-          <a:prstGeom prst="rect">
-            <a:avLst/>
-          </a:prstGeom>
-          <a:noFill/>
-          <a:ln/>
-        </p:spPr>
-        <p:txBody>
-          <a:bodyPr wrap="square" rtlCol="0" anchor="ctr"/>
-          <a:lstStyle/>
-          <a:p>
-            <a:pPr algn="ctr" indent="0" marL="0">
-              <a:buNone/>
-            </a:pPr>
-            <a:r>
-              <a:rPr lang="en-US" sz="1250" b="1" dirty="0">
-                <a:solidFill>
-                  <a:srgbClr val="FFFFFF"/>
-                </a:solidFill>
-                <a:latin typeface="Segoe UI" pitchFamily="34" charset="0"/>
-                <a:ea typeface="Segoe UI" pitchFamily="34" charset="-122"/>
-                <a:cs typeface="Segoe UI" pitchFamily="34" charset="-120"/>
-              </a:rPr>
-              <a:t>Daily Progress Report</a:t>
-            </a:r>
-            <a:endParaRPr lang="en-US" sz="1250" dirty="0"/>
-          </a:p>
-        </p:txBody>
-      </p:sp>
-      <p:sp>
-        <p:nvSpPr>
-          <p:cNvPr id="13" name="Shape 11"/>
-          <p:cNvSpPr/>
-          <p:nvPr/>
-        </p:nvSpPr>
-        <p:spPr>
-          <a:xfrm>
-            <a:off x="6281928" y="5029200"/>
-            <a:ext cx="2002536" cy="457200"/>
-          </a:xfrm>
-          <a:prstGeom prst="roundRect">
-            <a:avLst>
-              <a:gd name="adj" fmla="val 50000"/>
-            </a:avLst>
-          </a:prstGeom>
-          <a:solidFill>
             <a:srgbClr val="7C3AED"/>
           </a:solidFill>
           <a:ln/>
@@ -2415,13 +2176,13 @@
       </p:sp>
       <p:sp>
         <p:nvSpPr>
-          <p:cNvPr id="14" name="Text 12"/>
-          <p:cNvSpPr/>
-          <p:nvPr/>
-        </p:nvSpPr>
-        <p:spPr>
-          <a:xfrm>
-            <a:off x="6281928" y="5029200"/>
+          <p:cNvPr id="12" name="Text 10"/>
+          <p:cNvSpPr/>
+          <p:nvPr/>
+        </p:nvSpPr>
+        <p:spPr>
+          <a:xfrm>
+            <a:off x="3552444" y="5029200"/>
             <a:ext cx="2002536" cy="457200"/>
           </a:xfrm>
           <a:prstGeom prst="rect">
@@ -2466,7 +2227,7 @@
     <p:bg>
       <p:bgPr>
         <a:solidFill>
-          <a:srgbClr val="7C3AED"/>
+          <a:srgbClr val="FFFFFF"/>
         </a:solidFill>
       </p:bgPr>
     </p:bg>
@@ -2486,44 +2247,23 @@
       </p:grpSpPr>
       <p:sp>
         <p:nvSpPr>
-          <p:cNvPr id="2" name="Text 0"/>
-          <p:cNvSpPr/>
-          <p:nvPr/>
-        </p:nvSpPr>
-        <p:spPr>
-          <a:xfrm>
-            <a:off x="822960" y="2011680"/>
-            <a:ext cx="2743200" cy="1463040"/>
-          </a:xfrm>
-          <a:prstGeom prst="rect">
-            <a:avLst/>
-          </a:prstGeom>
-          <a:noFill/>
-          <a:ln/>
-        </p:spPr>
-        <p:txBody>
-          <a:bodyPr wrap="square" rtlCol="0" anchor="ctr"/>
-          <a:lstStyle/>
-          <a:p>
-            <a:pPr indent="0" marL="0">
-              <a:buNone/>
-            </a:pPr>
-            <a:r>
-              <a:rPr lang="en-US" sz="9000" b="1" dirty="0">
-                <a:solidFill>
-                  <a:srgbClr val="FFFFFF">
-                    <a:alpha val="30000"/>
-                  </a:srgbClr>
-                </a:solidFill>
-                <a:latin typeface="Segoe UI" pitchFamily="34" charset="0"/>
-                <a:ea typeface="Segoe UI" pitchFamily="34" charset="-122"/>
-                <a:cs typeface="Segoe UI" pitchFamily="34" charset="-120"/>
-              </a:rPr>
-              <a:t>03</a:t>
-            </a:r>
-            <a:endParaRPr lang="en-US" sz="9000" dirty="0"/>
-          </a:p>
-        </p:txBody>
+          <p:cNvPr id="2" name="Shape 0"/>
+          <p:cNvSpPr/>
+          <p:nvPr/>
+        </p:nvSpPr>
+        <p:spPr>
+          <a:xfrm>
+            <a:off x="0" y="0"/>
+            <a:ext cx="12191695" cy="1234440"/>
+          </a:xfrm>
+          <a:prstGeom prst="rect">
+            <a:avLst/>
+          </a:prstGeom>
+          <a:solidFill>
+            <a:srgbClr val="7C3AED"/>
+          </a:solidFill>
+          <a:ln/>
+        </p:spPr>
       </p:sp>
       <p:sp>
         <p:nvSpPr>
@@ -2533,8 +2273,8 @@
         </p:nvSpPr>
         <p:spPr>
           <a:xfrm>
-            <a:off x="868680" y="3429000"/>
-            <a:ext cx="1280160" cy="64008"/>
+            <a:off x="502920" y="310896"/>
+            <a:ext cx="82296" cy="621792"/>
           </a:xfrm>
           <a:prstGeom prst="rect">
             <a:avLst/>
@@ -2553,24 +2293,24 @@
         </p:nvSpPr>
         <p:spPr>
           <a:xfrm>
-            <a:off x="822960" y="3611880"/>
-            <a:ext cx="10058400" cy="914400"/>
-          </a:xfrm>
-          <a:prstGeom prst="rect">
-            <a:avLst/>
-          </a:prstGeom>
-          <a:noFill/>
-          <a:ln/>
-        </p:spPr>
-        <p:txBody>
-          <a:bodyPr wrap="square" rtlCol="0" anchor="ctr"/>
-          <a:lstStyle/>
-          <a:p>
-            <a:pPr indent="0" marL="0">
-              <a:buNone/>
-            </a:pPr>
-            <a:r>
-              <a:rPr lang="en-US" sz="4000" b="1" dirty="0">
+            <a:off x="777240" y="237744"/>
+            <a:ext cx="9601200" cy="502920"/>
+          </a:xfrm>
+          <a:prstGeom prst="rect">
+            <a:avLst/>
+          </a:prstGeom>
+          <a:noFill/>
+          <a:ln/>
+        </p:spPr>
+        <p:txBody>
+          <a:bodyPr wrap="square" rtlCol="0" anchor="ctr"/>
+          <a:lstStyle/>
+          <a:p>
+            <a:pPr indent="0" marL="0">
+              <a:buNone/>
+            </a:pPr>
+            <a:r>
+              <a:rPr lang="en-US" sz="2400" b="1" dirty="0">
                 <a:solidFill>
                   <a:srgbClr val="FFFFFF"/>
                 </a:solidFill>
@@ -2578,9 +2318,9 @@
                 <a:ea typeface="Segoe UI" pitchFamily="34" charset="-122"/>
                 <a:cs typeface="Segoe UI" pitchFamily="34" charset="-120"/>
               </a:rPr>
-              <a:t>Drawing Requests</a:t>
-            </a:r>
-            <a:endParaRPr lang="en-US" sz="4000" dirty="0"/>
+              <a:t>Tracking Every Ticket</a:t>
+            </a:r>
+            <a:endParaRPr lang="en-US" sz="2400" dirty="0"/>
           </a:p>
         </p:txBody>
       </p:sp>
@@ -2592,24 +2332,24 @@
         </p:nvSpPr>
         <p:spPr>
           <a:xfrm>
-            <a:off x="822960" y="4434840"/>
-            <a:ext cx="9144000" cy="548640"/>
-          </a:xfrm>
-          <a:prstGeom prst="rect">
-            <a:avLst/>
-          </a:prstGeom>
-          <a:noFill/>
-          <a:ln/>
-        </p:spPr>
-        <p:txBody>
-          <a:bodyPr wrap="square" rtlCol="0" anchor="ctr"/>
-          <a:lstStyle/>
-          <a:p>
-            <a:pPr indent="0" marL="0">
-              <a:buNone/>
-            </a:pPr>
-            <a:r>
-              <a:rPr lang="en-US" sz="1500" dirty="0">
+            <a:off x="777240" y="713232"/>
+            <a:ext cx="10515600" cy="365760"/>
+          </a:xfrm>
+          <a:prstGeom prst="rect">
+            <a:avLst/>
+          </a:prstGeom>
+          <a:noFill/>
+          <a:ln/>
+        </p:spPr>
+        <p:txBody>
+          <a:bodyPr wrap="square" rtlCol="0" anchor="ctr"/>
+          <a:lstStyle/>
+          <a:p>
+            <a:pPr indent="0" marL="0">
+              <a:buNone/>
+            </a:pPr>
+            <a:r>
+              <a:rPr lang="en-US" sz="1250" dirty="0">
                 <a:solidFill>
                   <a:srgbClr val="FFFFFF">
                     <a:alpha val="85000"/>
@@ -2619,9 +2359,421 @@
                 <a:ea typeface="Segoe UI" pitchFamily="34" charset="-122"/>
                 <a:cs typeface="Segoe UI" pitchFamily="34" charset="-120"/>
               </a:rPr>
-              <a:t>Raise it in seconds on site — track it through AGM, GM, and Planning until it's resolved.</a:t>
-            </a:r>
-            <a:endParaRPr lang="en-US" sz="1500" dirty="0"/>
+              <a:t>One list, searchable and filterable, for everything the site has ever asked Planning/Design for.</a:t>
+            </a:r>
+            <a:endParaRPr lang="en-US" sz="1250" dirty="0"/>
+          </a:p>
+        </p:txBody>
+      </p:sp>
+      <p:sp>
+        <p:nvSpPr>
+          <p:cNvPr id="6" name="Shape 4"/>
+          <p:cNvSpPr/>
+          <p:nvPr/>
+        </p:nvSpPr>
+        <p:spPr>
+          <a:xfrm>
+            <a:off x="640080" y="1819656"/>
+            <a:ext cx="82296" cy="82296"/>
+          </a:xfrm>
+          <a:prstGeom prst="rect">
+            <a:avLst/>
+          </a:prstGeom>
+          <a:solidFill>
+            <a:srgbClr val="7C3AED"/>
+          </a:solidFill>
+          <a:ln/>
+        </p:spPr>
+      </p:sp>
+      <p:sp>
+        <p:nvSpPr>
+          <p:cNvPr id="7" name="Text 5"/>
+          <p:cNvSpPr/>
+          <p:nvPr/>
+        </p:nvSpPr>
+        <p:spPr>
+          <a:xfrm>
+            <a:off x="896112" y="1682496"/>
+            <a:ext cx="4773168" cy="292608"/>
+          </a:xfrm>
+          <a:prstGeom prst="rect">
+            <a:avLst/>
+          </a:prstGeom>
+          <a:noFill/>
+          <a:ln/>
+        </p:spPr>
+        <p:txBody>
+          <a:bodyPr wrap="square" rtlCol="0" anchor="ctr"/>
+          <a:lstStyle/>
+          <a:p>
+            <a:pPr indent="0" marL="0">
+              <a:buNone/>
+            </a:pPr>
+            <a:r>
+              <a:rPr lang="en-US" sz="1450" b="1" dirty="0">
+                <a:solidFill>
+                  <a:srgbClr val="1A1A2E"/>
+                </a:solidFill>
+                <a:latin typeface="Segoe UI" pitchFamily="34" charset="0"/>
+                <a:ea typeface="Segoe UI" pitchFamily="34" charset="-122"/>
+                <a:cs typeface="Segoe UI" pitchFamily="34" charset="-120"/>
+              </a:rPr>
+              <a:t>Search &amp; filter</a:t>
+            </a:r>
+            <a:endParaRPr lang="en-US" sz="1450" dirty="0"/>
+          </a:p>
+        </p:txBody>
+      </p:sp>
+      <p:sp>
+        <p:nvSpPr>
+          <p:cNvPr id="8" name="Text 6"/>
+          <p:cNvSpPr/>
+          <p:nvPr/>
+        </p:nvSpPr>
+        <p:spPr>
+          <a:xfrm>
+            <a:off x="896112" y="1975104"/>
+            <a:ext cx="4773168" cy="566928"/>
+          </a:xfrm>
+          <a:prstGeom prst="rect">
+            <a:avLst/>
+          </a:prstGeom>
+          <a:noFill/>
+          <a:ln/>
+        </p:spPr>
+        <p:txBody>
+          <a:bodyPr wrap="square" rtlCol="0" anchor="ctr"/>
+          <a:lstStyle/>
+          <a:p>
+            <a:pPr indent="0" marL="0">
+              <a:lnSpc>
+                <a:spcPct val="115000"/>
+              </a:lnSpc>
+              <a:buNone/>
+            </a:pPr>
+            <a:r>
+              <a:rPr lang="en-US" sz="1150" dirty="0">
+                <a:solidFill>
+                  <a:srgbClr val="475569"/>
+                </a:solidFill>
+                <a:latin typeface="Segoe UI" pitchFamily="34" charset="0"/>
+                <a:ea typeface="Segoe UI" pitchFamily="34" charset="-122"/>
+                <a:cs typeface="Segoe UI" pitchFamily="34" charset="-120"/>
+              </a:rPr>
+              <a:t>By project, drawing type, priority, status, or a date range — find any ticket in seconds.</a:t>
+            </a:r>
+            <a:endParaRPr lang="en-US" sz="1150" dirty="0"/>
+          </a:p>
+        </p:txBody>
+      </p:sp>
+      <p:sp>
+        <p:nvSpPr>
+          <p:cNvPr id="9" name="Shape 7"/>
+          <p:cNvSpPr/>
+          <p:nvPr/>
+        </p:nvSpPr>
+        <p:spPr>
+          <a:xfrm>
+            <a:off x="640080" y="2752344"/>
+            <a:ext cx="82296" cy="82296"/>
+          </a:xfrm>
+          <a:prstGeom prst="rect">
+            <a:avLst/>
+          </a:prstGeom>
+          <a:solidFill>
+            <a:srgbClr val="7C3AED"/>
+          </a:solidFill>
+          <a:ln/>
+        </p:spPr>
+      </p:sp>
+      <p:sp>
+        <p:nvSpPr>
+          <p:cNvPr id="10" name="Text 8"/>
+          <p:cNvSpPr/>
+          <p:nvPr/>
+        </p:nvSpPr>
+        <p:spPr>
+          <a:xfrm>
+            <a:off x="896112" y="2615184"/>
+            <a:ext cx="4773168" cy="292608"/>
+          </a:xfrm>
+          <a:prstGeom prst="rect">
+            <a:avLst/>
+          </a:prstGeom>
+          <a:noFill/>
+          <a:ln/>
+        </p:spPr>
+        <p:txBody>
+          <a:bodyPr wrap="square" rtlCol="0" anchor="ctr"/>
+          <a:lstStyle/>
+          <a:p>
+            <a:pPr indent="0" marL="0">
+              <a:buNone/>
+            </a:pPr>
+            <a:r>
+              <a:rPr lang="en-US" sz="1450" b="1" dirty="0">
+                <a:solidFill>
+                  <a:srgbClr val="1A1A2E"/>
+                </a:solidFill>
+                <a:latin typeface="Segoe UI" pitchFamily="34" charset="0"/>
+                <a:ea typeface="Segoe UI" pitchFamily="34" charset="-122"/>
+                <a:cs typeface="Segoe UI" pitchFamily="34" charset="-120"/>
+              </a:rPr>
+              <a:t>Status at a glance</a:t>
+            </a:r>
+            <a:endParaRPr lang="en-US" sz="1450" dirty="0"/>
+          </a:p>
+        </p:txBody>
+      </p:sp>
+      <p:sp>
+        <p:nvSpPr>
+          <p:cNvPr id="11" name="Text 9"/>
+          <p:cNvSpPr/>
+          <p:nvPr/>
+        </p:nvSpPr>
+        <p:spPr>
+          <a:xfrm>
+            <a:off x="896112" y="2907792"/>
+            <a:ext cx="4773168" cy="566928"/>
+          </a:xfrm>
+          <a:prstGeom prst="rect">
+            <a:avLst/>
+          </a:prstGeom>
+          <a:noFill/>
+          <a:ln/>
+        </p:spPr>
+        <p:txBody>
+          <a:bodyPr wrap="square" rtlCol="0" anchor="ctr"/>
+          <a:lstStyle/>
+          <a:p>
+            <a:pPr indent="0" marL="0">
+              <a:lnSpc>
+                <a:spcPct val="115000"/>
+              </a:lnSpc>
+              <a:buNone/>
+            </a:pPr>
+            <a:r>
+              <a:rPr lang="en-US" sz="1150" dirty="0">
+                <a:solidFill>
+                  <a:srgbClr val="475569"/>
+                </a:solidFill>
+                <a:latin typeface="Segoe UI" pitchFamily="34" charset="0"/>
+                <a:ea typeface="Segoe UI" pitchFamily="34" charset="-122"/>
+                <a:cs typeface="Segoe UI" pitchFamily="34" charset="-120"/>
+              </a:rPr>
+              <a:t>Pending, Committed, Completed, or Delayed — colour-coded across the whole list.</a:t>
+            </a:r>
+            <a:endParaRPr lang="en-US" sz="1150" dirty="0"/>
+          </a:p>
+        </p:txBody>
+      </p:sp>
+      <p:sp>
+        <p:nvSpPr>
+          <p:cNvPr id="12" name="Shape 10"/>
+          <p:cNvSpPr/>
+          <p:nvPr/>
+        </p:nvSpPr>
+        <p:spPr>
+          <a:xfrm>
+            <a:off x="640080" y="3685032"/>
+            <a:ext cx="82296" cy="82296"/>
+          </a:xfrm>
+          <a:prstGeom prst="rect">
+            <a:avLst/>
+          </a:prstGeom>
+          <a:solidFill>
+            <a:srgbClr val="7C3AED"/>
+          </a:solidFill>
+          <a:ln/>
+        </p:spPr>
+      </p:sp>
+      <p:sp>
+        <p:nvSpPr>
+          <p:cNvPr id="13" name="Text 11"/>
+          <p:cNvSpPr/>
+          <p:nvPr/>
+        </p:nvSpPr>
+        <p:spPr>
+          <a:xfrm>
+            <a:off x="896112" y="3547872"/>
+            <a:ext cx="4773168" cy="292608"/>
+          </a:xfrm>
+          <a:prstGeom prst="rect">
+            <a:avLst/>
+          </a:prstGeom>
+          <a:noFill/>
+          <a:ln/>
+        </p:spPr>
+        <p:txBody>
+          <a:bodyPr wrap="square" rtlCol="0" anchor="ctr"/>
+          <a:lstStyle/>
+          <a:p>
+            <a:pPr indent="0" marL="0">
+              <a:buNone/>
+            </a:pPr>
+            <a:r>
+              <a:rPr lang="en-US" sz="1450" b="1" dirty="0">
+                <a:solidFill>
+                  <a:srgbClr val="1A1A2E"/>
+                </a:solidFill>
+                <a:latin typeface="Segoe UI" pitchFamily="34" charset="0"/>
+                <a:ea typeface="Segoe UI" pitchFamily="34" charset="-122"/>
+                <a:cs typeface="Segoe UI" pitchFamily="34" charset="-120"/>
+              </a:rPr>
+              <a:t>Everything in one row</a:t>
+            </a:r>
+            <a:endParaRPr lang="en-US" sz="1450" dirty="0"/>
+          </a:p>
+        </p:txBody>
+      </p:sp>
+      <p:sp>
+        <p:nvSpPr>
+          <p:cNvPr id="14" name="Text 12"/>
+          <p:cNvSpPr/>
+          <p:nvPr/>
+        </p:nvSpPr>
+        <p:spPr>
+          <a:xfrm>
+            <a:off x="896112" y="3840480"/>
+            <a:ext cx="4773168" cy="566928"/>
+          </a:xfrm>
+          <a:prstGeom prst="rect">
+            <a:avLst/>
+          </a:prstGeom>
+          <a:noFill/>
+          <a:ln/>
+        </p:spPr>
+        <p:txBody>
+          <a:bodyPr wrap="square" rtlCol="0" anchor="ctr"/>
+          <a:lstStyle/>
+          <a:p>
+            <a:pPr indent="0" marL="0">
+              <a:lnSpc>
+                <a:spcPct val="115000"/>
+              </a:lnSpc>
+              <a:buNone/>
+            </a:pPr>
+            <a:r>
+              <a:rPr lang="en-US" sz="1150" dirty="0">
+                <a:solidFill>
+                  <a:srgbClr val="475569"/>
+                </a:solidFill>
+                <a:latin typeface="Segoe UI" pitchFamily="34" charset="0"/>
+                <a:ea typeface="Segoe UI" pitchFamily="34" charset="-122"/>
+                <a:cs typeface="Segoe UI" pitchFamily="34" charset="-120"/>
+              </a:rPr>
+              <a:t>Ticket No, requester, assigned owner, priority, committed date, and actual completion — no digging required.</a:t>
+            </a:r>
+            <a:endParaRPr lang="en-US" sz="1150" dirty="0"/>
+          </a:p>
+        </p:txBody>
+      </p:sp>
+      <p:pic>
+        <p:nvPicPr>
+          <p:cNvPr id="15" name="Image 0" descr="shots/14_drawing_requests_list.png">    </p:cNvPr>
+          <p:cNvPicPr>
+            <a:picLocks noChangeAspect="1"/>
+          </p:cNvPicPr>
+          <p:nvPr/>
+        </p:nvPicPr>
+        <p:blipFill>
+          <a:blip r:embed="rId1"/>
+          <a:stretch>
+            <a:fillRect/>
+          </a:stretch>
+        </p:blipFill>
+        <p:spPr>
+          <a:xfrm>
+            <a:off x="5989320" y="1600200"/>
+            <a:ext cx="5669280" cy="4663440"/>
+          </a:xfrm>
+          <a:prstGeom prst="rect">
+            <a:avLst/>
+          </a:prstGeom>
+          <a:effectLst>
+            <a:outerShdw sx="100000" sy="100000" kx="0" ky="0" algn="bl" rotWithShape="0" blurRad="228600" dist="76200" dir="5400000">
+              <a:srgbClr val="1A1A2E">
+                <a:alpha val="35000"/>
+              </a:srgbClr>
+            </a:outerShdw>
+          </a:effectLst>
+        </p:spPr>
+      </p:pic>
+      <p:sp>
+        <p:nvSpPr>
+          <p:cNvPr id="16" name="Text 13"/>
+          <p:cNvSpPr/>
+          <p:nvPr/>
+        </p:nvSpPr>
+        <p:spPr>
+          <a:xfrm>
+            <a:off x="457200" y="6547104"/>
+            <a:ext cx="5486400" cy="274320"/>
+          </a:xfrm>
+          <a:prstGeom prst="rect">
+            <a:avLst/>
+          </a:prstGeom>
+          <a:noFill/>
+          <a:ln/>
+        </p:spPr>
+        <p:txBody>
+          <a:bodyPr wrap="square" rtlCol="0" anchor="ctr"/>
+          <a:lstStyle/>
+          <a:p>
+            <a:pPr indent="0" marL="0">
+              <a:buNone/>
+            </a:pPr>
+            <a:r>
+              <a:rPr lang="en-US" sz="900" dirty="0">
+                <a:solidFill>
+                  <a:srgbClr val="94A3B8"/>
+                </a:solidFill>
+                <a:latin typeface="Segoe UI" pitchFamily="34" charset="0"/>
+                <a:ea typeface="Segoe UI" pitchFamily="34" charset="-122"/>
+                <a:cs typeface="Segoe UI" pitchFamily="34" charset="-120"/>
+              </a:rPr>
+              <a:t>Nexora ERP  ·  DRI Dashboard Overview</a:t>
+            </a:r>
+            <a:endParaRPr lang="en-US" sz="900" dirty="0"/>
+          </a:p>
+        </p:txBody>
+      </p:sp>
+      <p:sp>
+        <p:nvSpPr>
+          <p:cNvPr id="17" name="Text 14"/>
+          <p:cNvSpPr/>
+          <p:nvPr/>
+        </p:nvSpPr>
+        <p:spPr>
+          <a:xfrm>
+            <a:off x="11521440" y="6547104"/>
+            <a:ext cx="365760" cy="274320"/>
+          </a:xfrm>
+          <a:prstGeom prst="rect">
+            <a:avLst/>
+          </a:prstGeom>
+          <a:noFill/>
+          <a:ln/>
+        </p:spPr>
+        <p:txBody>
+          <a:bodyPr wrap="square" rtlCol="0" anchor="ctr"/>
+          <a:lstStyle/>
+          <a:p>
+            <a:pPr algn="r" indent="0" marL="0">
+              <a:buNone/>
+            </a:pPr>
+            <a:r>
+              <a:rPr lang="en-US" sz="900" dirty="0">
+                <a:solidFill>
+                  <a:srgbClr val="94A3B8"/>
+                </a:solidFill>
+                <a:latin typeface="Segoe UI" pitchFamily="34" charset="0"/>
+                <a:ea typeface="Segoe UI" pitchFamily="34" charset="-122"/>
+                <a:cs typeface="Segoe UI" pitchFamily="34" charset="-120"/>
+              </a:rPr>
+              <a:t>8</a:t>
+            </a:r>
+            <a:endParaRPr lang="en-US" sz="900" dirty="0"/>
           </a:p>
         </p:txBody>
       </p:sp>
@@ -2730,7 +2882,7 @@
                 <a:ea typeface="Segoe UI" pitchFamily="34" charset="-122"/>
                 <a:cs typeface="Segoe UI" pitchFamily="34" charset="-120"/>
               </a:rPr>
-              <a:t>Raising a Request</a:t>
+              <a:t>The Full Ticket Lifecycle</a:t>
             </a:r>
             <a:endParaRPr lang="en-US" sz="2400" dirty="0"/>
           </a:p>
@@ -2771,7 +2923,7 @@
                 <a:ea typeface="Segoe UI" pitchFamily="34" charset="-122"/>
                 <a:cs typeface="Segoe UI" pitchFamily="34" charset="-120"/>
               </a:rPr>
-              <a:t>A DRI stuck without a drawing raises a ticket without ever leaving the Daily Progress Report page.</a:t>
+              <a:t>Four short stages carry a request from raised to resolved — each owned by a different role.</a:t>
             </a:r>
             <a:endParaRPr lang="en-US" sz="1250" dirty="0"/>
           </a:p>
@@ -2830,7 +2982,7 @@
                 <a:ea typeface="Segoe UI" pitchFamily="34" charset="-122"/>
                 <a:cs typeface="Segoe UI" pitchFamily="34" charset="-120"/>
               </a:rPr>
-              <a:t>One button, right where it's needed</a:t>
+              <a:t>AGM Response</a:t>
             </a:r>
             <a:endParaRPr lang="en-US" sz="1450" dirty="0"/>
           </a:p>
@@ -2872,7 +3024,7 @@
                 <a:ea typeface="Segoe UI" pitchFamily="34" charset="-122"/>
                 <a:cs typeface="Segoe UI" pitchFamily="34" charset="-120"/>
               </a:rPr>
-              <a:t>"Drawing Request" sits next to "New Report" on the Daily Progress Report page.</a:t>
+              <a:t>Assigns the ticket to someone and commits a target date.</a:t>
             </a:r>
             <a:endParaRPr lang="en-US" sz="1150" dirty="0"/>
           </a:p>
@@ -2931,7 +3083,7 @@
                 <a:ea typeface="Segoe UI" pitchFamily="34" charset="-122"/>
                 <a:cs typeface="Segoe UI" pitchFamily="34" charset="-120"/>
               </a:rPr>
-              <a:t>Just the essentials</a:t>
+              <a:t>GM — Priority</a:t>
             </a:r>
             <a:endParaRPr lang="en-US" sz="1450" dirty="0"/>
           </a:p>
@@ -2973,7 +3125,7 @@
                 <a:ea typeface="Segoe UI" pitchFamily="34" charset="-122"/>
                 <a:cs typeface="Segoe UI" pitchFamily="34" charset="-120"/>
               </a:rPr>
-              <a:t>Project, a description of what's needed, drawing type (Architectural / Structural / MEP / Civil…), and requester name.</a:t>
+              <a:t>Sets how urgently it needs to move.</a:t>
             </a:r>
             <a:endParaRPr lang="en-US" sz="1150" dirty="0"/>
           </a:p>
@@ -3032,7 +3184,7 @@
                 <a:ea typeface="Segoe UI" pitchFamily="34" charset="-122"/>
                 <a:cs typeface="Segoe UI" pitchFamily="34" charset="-120"/>
               </a:rPr>
-              <a:t>Auto-numbered on submit</a:t>
+              <a:t>Planning — Status</a:t>
             </a:r>
             <a:endParaRPr lang="en-US" sz="1450" dirty="0"/>
           </a:p>
@@ -3074,7 +3226,7 @@
                 <a:ea typeface="Segoe UI" pitchFamily="34" charset="-122"/>
                 <a:cs typeface="Segoe UI" pitchFamily="34" charset="-120"/>
               </a:rPr>
-              <a:t>Every request gets its own ticket number (e.g. DR-0003) the moment it's raised.</a:t>
+              <a:t>Updates progress through to an actual completion date.</a:t>
             </a:r>
             <a:endParaRPr lang="en-US" sz="1150" dirty="0"/>
           </a:p>
@@ -3133,7 +3285,7 @@
                 <a:ea typeface="Segoe UI" pitchFamily="34" charset="-122"/>
                 <a:cs typeface="Segoe UI" pitchFamily="34" charset="-120"/>
               </a:rPr>
-              <a:t>Also available publicly</a:t>
+              <a:t>Verification</a:t>
             </a:r>
             <a:endParaRPr lang="en-US" sz="1450" dirty="0"/>
           </a:p>
@@ -3175,7 +3327,7 @@
                 <a:ea typeface="Segoe UI" pitchFamily="34" charset="-122"/>
                 <a:cs typeface="Segoe UI" pitchFamily="34" charset="-120"/>
               </a:rPr>
-              <a:t>A standalone no-login form covers anyone on site without an account.</a:t>
+              <a:t>Planning and the project team both confirm it's genuinely resolved.</a:t>
             </a:r>
             <a:endParaRPr lang="en-US" sz="1150" dirty="0"/>
           </a:p>
@@ -3183,7 +3335,7 @@
       </p:sp>
       <p:pic>
         <p:nvPicPr>
-          <p:cNvPr id="18" name="Image 0" descr="shots/12_drawing_request_filled.png">    </p:cNvPr>
+          <p:cNvPr id="18" name="Image 0" descr="shots/16_drawing_request_edit_modal.png">    </p:cNvPr>
           <p:cNvPicPr>
             <a:picLocks noChangeAspect="1"/>
           </p:cNvPicPr>
@@ -3284,7 +3436,7 @@
                 <a:ea typeface="Segoe UI" pitchFamily="34" charset="-122"/>
                 <a:cs typeface="Segoe UI" pitchFamily="34" charset="-120"/>
               </a:rPr>
-              <a:t>11</a:t>
+              <a:t>9</a:t>
             </a:r>
             <a:endParaRPr lang="en-US" sz="900" dirty="0"/>
           </a:p>
@@ -3301,1235 +3453,6 @@
 <file path=ppt/slides/slide12.xml><?xml version="1.0" encoding="utf-8"?>
 <p:sld xmlns:a="http://schemas.openxmlformats.org/drawingml/2006/main" xmlns:r="http://schemas.openxmlformats.org/officeDocument/2006/relationships" xmlns:p="http://schemas.openxmlformats.org/presentationml/2006/main">
   <p:cSld name="Slide 12">
-    <p:bg>
-      <p:bgPr>
-        <a:solidFill>
-          <a:srgbClr val="FFFFFF"/>
-        </a:solidFill>
-      </p:bgPr>
-    </p:bg>
-    <p:spTree>
-      <p:nvGrpSpPr>
-        <p:cNvPr id="1" name=""/>
-        <p:cNvGrpSpPr/>
-        <p:nvPr/>
-      </p:nvGrpSpPr>
-      <p:grpSpPr>
-        <a:xfrm>
-          <a:off x="0" y="0"/>
-          <a:ext cx="0" cy="0"/>
-          <a:chOff x="0" y="0"/>
-          <a:chExt cx="0" cy="0"/>
-        </a:xfrm>
-      </p:grpSpPr>
-      <p:sp>
-        <p:nvSpPr>
-          <p:cNvPr id="2" name="Shape 0"/>
-          <p:cNvSpPr/>
-          <p:nvPr/>
-        </p:nvSpPr>
-        <p:spPr>
-          <a:xfrm>
-            <a:off x="0" y="0"/>
-            <a:ext cx="12191695" cy="1234440"/>
-          </a:xfrm>
-          <a:prstGeom prst="rect">
-            <a:avLst/>
-          </a:prstGeom>
-          <a:solidFill>
-            <a:srgbClr val="7C3AED"/>
-          </a:solidFill>
-          <a:ln/>
-        </p:spPr>
-      </p:sp>
-      <p:sp>
-        <p:nvSpPr>
-          <p:cNvPr id="3" name="Shape 1"/>
-          <p:cNvSpPr/>
-          <p:nvPr/>
-        </p:nvSpPr>
-        <p:spPr>
-          <a:xfrm>
-            <a:off x="502920" y="310896"/>
-            <a:ext cx="82296" cy="621792"/>
-          </a:xfrm>
-          <a:prstGeom prst="rect">
-            <a:avLst/>
-          </a:prstGeom>
-          <a:solidFill>
-            <a:srgbClr val="FFFFFF"/>
-          </a:solidFill>
-          <a:ln/>
-        </p:spPr>
-      </p:sp>
-      <p:sp>
-        <p:nvSpPr>
-          <p:cNvPr id="4" name="Text 2"/>
-          <p:cNvSpPr/>
-          <p:nvPr/>
-        </p:nvSpPr>
-        <p:spPr>
-          <a:xfrm>
-            <a:off x="777240" y="237744"/>
-            <a:ext cx="9601200" cy="502920"/>
-          </a:xfrm>
-          <a:prstGeom prst="rect">
-            <a:avLst/>
-          </a:prstGeom>
-          <a:noFill/>
-          <a:ln/>
-        </p:spPr>
-        <p:txBody>
-          <a:bodyPr wrap="square" rtlCol="0" anchor="ctr"/>
-          <a:lstStyle/>
-          <a:p>
-            <a:pPr indent="0" marL="0">
-              <a:buNone/>
-            </a:pPr>
-            <a:r>
-              <a:rPr lang="en-US" sz="2400" b="1" dirty="0">
-                <a:solidFill>
-                  <a:srgbClr val="FFFFFF"/>
-                </a:solidFill>
-                <a:latin typeface="Segoe UI" pitchFamily="34" charset="0"/>
-                <a:ea typeface="Segoe UI" pitchFamily="34" charset="-122"/>
-                <a:cs typeface="Segoe UI" pitchFamily="34" charset="-120"/>
-              </a:rPr>
-              <a:t>Tracking Every Ticket</a:t>
-            </a:r>
-            <a:endParaRPr lang="en-US" sz="2400" dirty="0"/>
-          </a:p>
-        </p:txBody>
-      </p:sp>
-      <p:sp>
-        <p:nvSpPr>
-          <p:cNvPr id="5" name="Text 3"/>
-          <p:cNvSpPr/>
-          <p:nvPr/>
-        </p:nvSpPr>
-        <p:spPr>
-          <a:xfrm>
-            <a:off x="777240" y="713232"/>
-            <a:ext cx="10515600" cy="365760"/>
-          </a:xfrm>
-          <a:prstGeom prst="rect">
-            <a:avLst/>
-          </a:prstGeom>
-          <a:noFill/>
-          <a:ln/>
-        </p:spPr>
-        <p:txBody>
-          <a:bodyPr wrap="square" rtlCol="0" anchor="ctr"/>
-          <a:lstStyle/>
-          <a:p>
-            <a:pPr indent="0" marL="0">
-              <a:buNone/>
-            </a:pPr>
-            <a:r>
-              <a:rPr lang="en-US" sz="1250" dirty="0">
-                <a:solidFill>
-                  <a:srgbClr val="FFFFFF">
-                    <a:alpha val="85000"/>
-                  </a:srgbClr>
-                </a:solidFill>
-                <a:latin typeface="Segoe UI" pitchFamily="34" charset="0"/>
-                <a:ea typeface="Segoe UI" pitchFamily="34" charset="-122"/>
-                <a:cs typeface="Segoe UI" pitchFamily="34" charset="-120"/>
-              </a:rPr>
-              <a:t>One list, searchable and filterable, for everything the site has ever asked Planning/Design for.</a:t>
-            </a:r>
-            <a:endParaRPr lang="en-US" sz="1250" dirty="0"/>
-          </a:p>
-        </p:txBody>
-      </p:sp>
-      <p:sp>
-        <p:nvSpPr>
-          <p:cNvPr id="6" name="Shape 4"/>
-          <p:cNvSpPr/>
-          <p:nvPr/>
-        </p:nvSpPr>
-        <p:spPr>
-          <a:xfrm>
-            <a:off x="640080" y="1819656"/>
-            <a:ext cx="82296" cy="82296"/>
-          </a:xfrm>
-          <a:prstGeom prst="rect">
-            <a:avLst/>
-          </a:prstGeom>
-          <a:solidFill>
-            <a:srgbClr val="7C3AED"/>
-          </a:solidFill>
-          <a:ln/>
-        </p:spPr>
-      </p:sp>
-      <p:sp>
-        <p:nvSpPr>
-          <p:cNvPr id="7" name="Text 5"/>
-          <p:cNvSpPr/>
-          <p:nvPr/>
-        </p:nvSpPr>
-        <p:spPr>
-          <a:xfrm>
-            <a:off x="896112" y="1682496"/>
-            <a:ext cx="4773168" cy="292608"/>
-          </a:xfrm>
-          <a:prstGeom prst="rect">
-            <a:avLst/>
-          </a:prstGeom>
-          <a:noFill/>
-          <a:ln/>
-        </p:spPr>
-        <p:txBody>
-          <a:bodyPr wrap="square" rtlCol="0" anchor="ctr"/>
-          <a:lstStyle/>
-          <a:p>
-            <a:pPr indent="0" marL="0">
-              <a:buNone/>
-            </a:pPr>
-            <a:r>
-              <a:rPr lang="en-US" sz="1450" b="1" dirty="0">
-                <a:solidFill>
-                  <a:srgbClr val="1A1A2E"/>
-                </a:solidFill>
-                <a:latin typeface="Segoe UI" pitchFamily="34" charset="0"/>
-                <a:ea typeface="Segoe UI" pitchFamily="34" charset="-122"/>
-                <a:cs typeface="Segoe UI" pitchFamily="34" charset="-120"/>
-              </a:rPr>
-              <a:t>Search &amp; filter</a:t>
-            </a:r>
-            <a:endParaRPr lang="en-US" sz="1450" dirty="0"/>
-          </a:p>
-        </p:txBody>
-      </p:sp>
-      <p:sp>
-        <p:nvSpPr>
-          <p:cNvPr id="8" name="Text 6"/>
-          <p:cNvSpPr/>
-          <p:nvPr/>
-        </p:nvSpPr>
-        <p:spPr>
-          <a:xfrm>
-            <a:off x="896112" y="1975104"/>
-            <a:ext cx="4773168" cy="566928"/>
-          </a:xfrm>
-          <a:prstGeom prst="rect">
-            <a:avLst/>
-          </a:prstGeom>
-          <a:noFill/>
-          <a:ln/>
-        </p:spPr>
-        <p:txBody>
-          <a:bodyPr wrap="square" rtlCol="0" anchor="ctr"/>
-          <a:lstStyle/>
-          <a:p>
-            <a:pPr indent="0" marL="0">
-              <a:lnSpc>
-                <a:spcPct val="115000"/>
-              </a:lnSpc>
-              <a:buNone/>
-            </a:pPr>
-            <a:r>
-              <a:rPr lang="en-US" sz="1150" dirty="0">
-                <a:solidFill>
-                  <a:srgbClr val="475569"/>
-                </a:solidFill>
-                <a:latin typeface="Segoe UI" pitchFamily="34" charset="0"/>
-                <a:ea typeface="Segoe UI" pitchFamily="34" charset="-122"/>
-                <a:cs typeface="Segoe UI" pitchFamily="34" charset="-120"/>
-              </a:rPr>
-              <a:t>By project, drawing type, priority, status, or a date range — find any ticket in seconds.</a:t>
-            </a:r>
-            <a:endParaRPr lang="en-US" sz="1150" dirty="0"/>
-          </a:p>
-        </p:txBody>
-      </p:sp>
-      <p:sp>
-        <p:nvSpPr>
-          <p:cNvPr id="9" name="Shape 7"/>
-          <p:cNvSpPr/>
-          <p:nvPr/>
-        </p:nvSpPr>
-        <p:spPr>
-          <a:xfrm>
-            <a:off x="640080" y="2752344"/>
-            <a:ext cx="82296" cy="82296"/>
-          </a:xfrm>
-          <a:prstGeom prst="rect">
-            <a:avLst/>
-          </a:prstGeom>
-          <a:solidFill>
-            <a:srgbClr val="7C3AED"/>
-          </a:solidFill>
-          <a:ln/>
-        </p:spPr>
-      </p:sp>
-      <p:sp>
-        <p:nvSpPr>
-          <p:cNvPr id="10" name="Text 8"/>
-          <p:cNvSpPr/>
-          <p:nvPr/>
-        </p:nvSpPr>
-        <p:spPr>
-          <a:xfrm>
-            <a:off x="896112" y="2615184"/>
-            <a:ext cx="4773168" cy="292608"/>
-          </a:xfrm>
-          <a:prstGeom prst="rect">
-            <a:avLst/>
-          </a:prstGeom>
-          <a:noFill/>
-          <a:ln/>
-        </p:spPr>
-        <p:txBody>
-          <a:bodyPr wrap="square" rtlCol="0" anchor="ctr"/>
-          <a:lstStyle/>
-          <a:p>
-            <a:pPr indent="0" marL="0">
-              <a:buNone/>
-            </a:pPr>
-            <a:r>
-              <a:rPr lang="en-US" sz="1450" b="1" dirty="0">
-                <a:solidFill>
-                  <a:srgbClr val="1A1A2E"/>
-                </a:solidFill>
-                <a:latin typeface="Segoe UI" pitchFamily="34" charset="0"/>
-                <a:ea typeface="Segoe UI" pitchFamily="34" charset="-122"/>
-                <a:cs typeface="Segoe UI" pitchFamily="34" charset="-120"/>
-              </a:rPr>
-              <a:t>Status at a glance</a:t>
-            </a:r>
-            <a:endParaRPr lang="en-US" sz="1450" dirty="0"/>
-          </a:p>
-        </p:txBody>
-      </p:sp>
-      <p:sp>
-        <p:nvSpPr>
-          <p:cNvPr id="11" name="Text 9"/>
-          <p:cNvSpPr/>
-          <p:nvPr/>
-        </p:nvSpPr>
-        <p:spPr>
-          <a:xfrm>
-            <a:off x="896112" y="2907792"/>
-            <a:ext cx="4773168" cy="566928"/>
-          </a:xfrm>
-          <a:prstGeom prst="rect">
-            <a:avLst/>
-          </a:prstGeom>
-          <a:noFill/>
-          <a:ln/>
-        </p:spPr>
-        <p:txBody>
-          <a:bodyPr wrap="square" rtlCol="0" anchor="ctr"/>
-          <a:lstStyle/>
-          <a:p>
-            <a:pPr indent="0" marL="0">
-              <a:lnSpc>
-                <a:spcPct val="115000"/>
-              </a:lnSpc>
-              <a:buNone/>
-            </a:pPr>
-            <a:r>
-              <a:rPr lang="en-US" sz="1150" dirty="0">
-                <a:solidFill>
-                  <a:srgbClr val="475569"/>
-                </a:solidFill>
-                <a:latin typeface="Segoe UI" pitchFamily="34" charset="0"/>
-                <a:ea typeface="Segoe UI" pitchFamily="34" charset="-122"/>
-                <a:cs typeface="Segoe UI" pitchFamily="34" charset="-120"/>
-              </a:rPr>
-              <a:t>Pending, Committed, Completed, or Delayed — colour-coded across the whole list.</a:t>
-            </a:r>
-            <a:endParaRPr lang="en-US" sz="1150" dirty="0"/>
-          </a:p>
-        </p:txBody>
-      </p:sp>
-      <p:sp>
-        <p:nvSpPr>
-          <p:cNvPr id="12" name="Shape 10"/>
-          <p:cNvSpPr/>
-          <p:nvPr/>
-        </p:nvSpPr>
-        <p:spPr>
-          <a:xfrm>
-            <a:off x="640080" y="3685032"/>
-            <a:ext cx="82296" cy="82296"/>
-          </a:xfrm>
-          <a:prstGeom prst="rect">
-            <a:avLst/>
-          </a:prstGeom>
-          <a:solidFill>
-            <a:srgbClr val="7C3AED"/>
-          </a:solidFill>
-          <a:ln/>
-        </p:spPr>
-      </p:sp>
-      <p:sp>
-        <p:nvSpPr>
-          <p:cNvPr id="13" name="Text 11"/>
-          <p:cNvSpPr/>
-          <p:nvPr/>
-        </p:nvSpPr>
-        <p:spPr>
-          <a:xfrm>
-            <a:off x="896112" y="3547872"/>
-            <a:ext cx="4773168" cy="292608"/>
-          </a:xfrm>
-          <a:prstGeom prst="rect">
-            <a:avLst/>
-          </a:prstGeom>
-          <a:noFill/>
-          <a:ln/>
-        </p:spPr>
-        <p:txBody>
-          <a:bodyPr wrap="square" rtlCol="0" anchor="ctr"/>
-          <a:lstStyle/>
-          <a:p>
-            <a:pPr indent="0" marL="0">
-              <a:buNone/>
-            </a:pPr>
-            <a:r>
-              <a:rPr lang="en-US" sz="1450" b="1" dirty="0">
-                <a:solidFill>
-                  <a:srgbClr val="1A1A2E"/>
-                </a:solidFill>
-                <a:latin typeface="Segoe UI" pitchFamily="34" charset="0"/>
-                <a:ea typeface="Segoe UI" pitchFamily="34" charset="-122"/>
-                <a:cs typeface="Segoe UI" pitchFamily="34" charset="-120"/>
-              </a:rPr>
-              <a:t>Everything in one row</a:t>
-            </a:r>
-            <a:endParaRPr lang="en-US" sz="1450" dirty="0"/>
-          </a:p>
-        </p:txBody>
-      </p:sp>
-      <p:sp>
-        <p:nvSpPr>
-          <p:cNvPr id="14" name="Text 12"/>
-          <p:cNvSpPr/>
-          <p:nvPr/>
-        </p:nvSpPr>
-        <p:spPr>
-          <a:xfrm>
-            <a:off x="896112" y="3840480"/>
-            <a:ext cx="4773168" cy="566928"/>
-          </a:xfrm>
-          <a:prstGeom prst="rect">
-            <a:avLst/>
-          </a:prstGeom>
-          <a:noFill/>
-          <a:ln/>
-        </p:spPr>
-        <p:txBody>
-          <a:bodyPr wrap="square" rtlCol="0" anchor="ctr"/>
-          <a:lstStyle/>
-          <a:p>
-            <a:pPr indent="0" marL="0">
-              <a:lnSpc>
-                <a:spcPct val="115000"/>
-              </a:lnSpc>
-              <a:buNone/>
-            </a:pPr>
-            <a:r>
-              <a:rPr lang="en-US" sz="1150" dirty="0">
-                <a:solidFill>
-                  <a:srgbClr val="475569"/>
-                </a:solidFill>
-                <a:latin typeface="Segoe UI" pitchFamily="34" charset="0"/>
-                <a:ea typeface="Segoe UI" pitchFamily="34" charset="-122"/>
-                <a:cs typeface="Segoe UI" pitchFamily="34" charset="-120"/>
-              </a:rPr>
-              <a:t>Ticket No, requester, assigned owner, priority, committed date, and actual completion — no digging required.</a:t>
-            </a:r>
-            <a:endParaRPr lang="en-US" sz="1150" dirty="0"/>
-          </a:p>
-        </p:txBody>
-      </p:sp>
-      <p:pic>
-        <p:nvPicPr>
-          <p:cNvPr id="15" name="Image 0" descr="shots/14_drawing_requests_list.png">    </p:cNvPr>
-          <p:cNvPicPr>
-            <a:picLocks noChangeAspect="1"/>
-          </p:cNvPicPr>
-          <p:nvPr/>
-        </p:nvPicPr>
-        <p:blipFill>
-          <a:blip r:embed="rId1"/>
-          <a:stretch>
-            <a:fillRect/>
-          </a:stretch>
-        </p:blipFill>
-        <p:spPr>
-          <a:xfrm>
-            <a:off x="5989320" y="1600200"/>
-            <a:ext cx="5669280" cy="4663440"/>
-          </a:xfrm>
-          <a:prstGeom prst="rect">
-            <a:avLst/>
-          </a:prstGeom>
-          <a:effectLst>
-            <a:outerShdw sx="100000" sy="100000" kx="0" ky="0" algn="bl" rotWithShape="0" blurRad="228600" dist="76200" dir="5400000">
-              <a:srgbClr val="1A1A2E">
-                <a:alpha val="35000"/>
-              </a:srgbClr>
-            </a:outerShdw>
-          </a:effectLst>
-        </p:spPr>
-      </p:pic>
-      <p:sp>
-        <p:nvSpPr>
-          <p:cNvPr id="16" name="Text 13"/>
-          <p:cNvSpPr/>
-          <p:nvPr/>
-        </p:nvSpPr>
-        <p:spPr>
-          <a:xfrm>
-            <a:off x="457200" y="6547104"/>
-            <a:ext cx="5486400" cy="274320"/>
-          </a:xfrm>
-          <a:prstGeom prst="rect">
-            <a:avLst/>
-          </a:prstGeom>
-          <a:noFill/>
-          <a:ln/>
-        </p:spPr>
-        <p:txBody>
-          <a:bodyPr wrap="square" rtlCol="0" anchor="ctr"/>
-          <a:lstStyle/>
-          <a:p>
-            <a:pPr indent="0" marL="0">
-              <a:buNone/>
-            </a:pPr>
-            <a:r>
-              <a:rPr lang="en-US" sz="900" dirty="0">
-                <a:solidFill>
-                  <a:srgbClr val="94A3B8"/>
-                </a:solidFill>
-                <a:latin typeface="Segoe UI" pitchFamily="34" charset="0"/>
-                <a:ea typeface="Segoe UI" pitchFamily="34" charset="-122"/>
-                <a:cs typeface="Segoe UI" pitchFamily="34" charset="-120"/>
-              </a:rPr>
-              <a:t>Nexora ERP  ·  DRI Dashboard Overview</a:t>
-            </a:r>
-            <a:endParaRPr lang="en-US" sz="900" dirty="0"/>
-          </a:p>
-        </p:txBody>
-      </p:sp>
-      <p:sp>
-        <p:nvSpPr>
-          <p:cNvPr id="17" name="Text 14"/>
-          <p:cNvSpPr/>
-          <p:nvPr/>
-        </p:nvSpPr>
-        <p:spPr>
-          <a:xfrm>
-            <a:off x="11521440" y="6547104"/>
-            <a:ext cx="365760" cy="274320"/>
-          </a:xfrm>
-          <a:prstGeom prst="rect">
-            <a:avLst/>
-          </a:prstGeom>
-          <a:noFill/>
-          <a:ln/>
-        </p:spPr>
-        <p:txBody>
-          <a:bodyPr wrap="square" rtlCol="0" anchor="ctr"/>
-          <a:lstStyle/>
-          <a:p>
-            <a:pPr algn="r" indent="0" marL="0">
-              <a:buNone/>
-            </a:pPr>
-            <a:r>
-              <a:rPr lang="en-US" sz="900" dirty="0">
-                <a:solidFill>
-                  <a:srgbClr val="94A3B8"/>
-                </a:solidFill>
-                <a:latin typeface="Segoe UI" pitchFamily="34" charset="0"/>
-                <a:ea typeface="Segoe UI" pitchFamily="34" charset="-122"/>
-                <a:cs typeface="Segoe UI" pitchFamily="34" charset="-120"/>
-              </a:rPr>
-              <a:t>12</a:t>
-            </a:r>
-            <a:endParaRPr lang="en-US" sz="900" dirty="0"/>
-          </a:p>
-        </p:txBody>
-      </p:sp>
-    </p:spTree>
-  </p:cSld>
-  <p:clrMapOvr>
-    <a:masterClrMapping/>
-  </p:clrMapOvr>
-</p:sld>
-</file>
-
-<file path=ppt/slides/slide13.xml><?xml version="1.0" encoding="utf-8"?>
-<p:sld xmlns:a="http://schemas.openxmlformats.org/drawingml/2006/main" xmlns:r="http://schemas.openxmlformats.org/officeDocument/2006/relationships" xmlns:p="http://schemas.openxmlformats.org/presentationml/2006/main">
-  <p:cSld name="Slide 13">
-    <p:bg>
-      <p:bgPr>
-        <a:solidFill>
-          <a:srgbClr val="FFFFFF"/>
-        </a:solidFill>
-      </p:bgPr>
-    </p:bg>
-    <p:spTree>
-      <p:nvGrpSpPr>
-        <p:cNvPr id="1" name=""/>
-        <p:cNvGrpSpPr/>
-        <p:nvPr/>
-      </p:nvGrpSpPr>
-      <p:grpSpPr>
-        <a:xfrm>
-          <a:off x="0" y="0"/>
-          <a:ext cx="0" cy="0"/>
-          <a:chOff x="0" y="0"/>
-          <a:chExt cx="0" cy="0"/>
-        </a:xfrm>
-      </p:grpSpPr>
-      <p:sp>
-        <p:nvSpPr>
-          <p:cNvPr id="2" name="Shape 0"/>
-          <p:cNvSpPr/>
-          <p:nvPr/>
-        </p:nvSpPr>
-        <p:spPr>
-          <a:xfrm>
-            <a:off x="0" y="0"/>
-            <a:ext cx="12191695" cy="1234440"/>
-          </a:xfrm>
-          <a:prstGeom prst="rect">
-            <a:avLst/>
-          </a:prstGeom>
-          <a:solidFill>
-            <a:srgbClr val="7C3AED"/>
-          </a:solidFill>
-          <a:ln/>
-        </p:spPr>
-      </p:sp>
-      <p:sp>
-        <p:nvSpPr>
-          <p:cNvPr id="3" name="Shape 1"/>
-          <p:cNvSpPr/>
-          <p:nvPr/>
-        </p:nvSpPr>
-        <p:spPr>
-          <a:xfrm>
-            <a:off x="502920" y="310896"/>
-            <a:ext cx="82296" cy="621792"/>
-          </a:xfrm>
-          <a:prstGeom prst="rect">
-            <a:avLst/>
-          </a:prstGeom>
-          <a:solidFill>
-            <a:srgbClr val="FFFFFF"/>
-          </a:solidFill>
-          <a:ln/>
-        </p:spPr>
-      </p:sp>
-      <p:sp>
-        <p:nvSpPr>
-          <p:cNvPr id="4" name="Text 2"/>
-          <p:cNvSpPr/>
-          <p:nvPr/>
-        </p:nvSpPr>
-        <p:spPr>
-          <a:xfrm>
-            <a:off x="777240" y="237744"/>
-            <a:ext cx="9601200" cy="502920"/>
-          </a:xfrm>
-          <a:prstGeom prst="rect">
-            <a:avLst/>
-          </a:prstGeom>
-          <a:noFill/>
-          <a:ln/>
-        </p:spPr>
-        <p:txBody>
-          <a:bodyPr wrap="square" rtlCol="0" anchor="ctr"/>
-          <a:lstStyle/>
-          <a:p>
-            <a:pPr indent="0" marL="0">
-              <a:buNone/>
-            </a:pPr>
-            <a:r>
-              <a:rPr lang="en-US" sz="2400" b="1" dirty="0">
-                <a:solidFill>
-                  <a:srgbClr val="FFFFFF"/>
-                </a:solidFill>
-                <a:latin typeface="Segoe UI" pitchFamily="34" charset="0"/>
-                <a:ea typeface="Segoe UI" pitchFamily="34" charset="-122"/>
-                <a:cs typeface="Segoe UI" pitchFamily="34" charset="-120"/>
-              </a:rPr>
-              <a:t>The Full Ticket Lifecycle</a:t>
-            </a:r>
-            <a:endParaRPr lang="en-US" sz="2400" dirty="0"/>
-          </a:p>
-        </p:txBody>
-      </p:sp>
-      <p:sp>
-        <p:nvSpPr>
-          <p:cNvPr id="5" name="Text 3"/>
-          <p:cNvSpPr/>
-          <p:nvPr/>
-        </p:nvSpPr>
-        <p:spPr>
-          <a:xfrm>
-            <a:off x="777240" y="713232"/>
-            <a:ext cx="10515600" cy="365760"/>
-          </a:xfrm>
-          <a:prstGeom prst="rect">
-            <a:avLst/>
-          </a:prstGeom>
-          <a:noFill/>
-          <a:ln/>
-        </p:spPr>
-        <p:txBody>
-          <a:bodyPr wrap="square" rtlCol="0" anchor="ctr"/>
-          <a:lstStyle/>
-          <a:p>
-            <a:pPr indent="0" marL="0">
-              <a:buNone/>
-            </a:pPr>
-            <a:r>
-              <a:rPr lang="en-US" sz="1250" dirty="0">
-                <a:solidFill>
-                  <a:srgbClr val="FFFFFF">
-                    <a:alpha val="85000"/>
-                  </a:srgbClr>
-                </a:solidFill>
-                <a:latin typeface="Segoe UI" pitchFamily="34" charset="0"/>
-                <a:ea typeface="Segoe UI" pitchFamily="34" charset="-122"/>
-                <a:cs typeface="Segoe UI" pitchFamily="34" charset="-120"/>
-              </a:rPr>
-              <a:t>Four short stages carry a request from raised to resolved — each owned by a different role.</a:t>
-            </a:r>
-            <a:endParaRPr lang="en-US" sz="1250" dirty="0"/>
-          </a:p>
-        </p:txBody>
-      </p:sp>
-      <p:sp>
-        <p:nvSpPr>
-          <p:cNvPr id="6" name="Shape 4"/>
-          <p:cNvSpPr/>
-          <p:nvPr/>
-        </p:nvSpPr>
-        <p:spPr>
-          <a:xfrm>
-            <a:off x="640080" y="1819656"/>
-            <a:ext cx="82296" cy="82296"/>
-          </a:xfrm>
-          <a:prstGeom prst="rect">
-            <a:avLst/>
-          </a:prstGeom>
-          <a:solidFill>
-            <a:srgbClr val="7C3AED"/>
-          </a:solidFill>
-          <a:ln/>
-        </p:spPr>
-      </p:sp>
-      <p:sp>
-        <p:nvSpPr>
-          <p:cNvPr id="7" name="Text 5"/>
-          <p:cNvSpPr/>
-          <p:nvPr/>
-        </p:nvSpPr>
-        <p:spPr>
-          <a:xfrm>
-            <a:off x="896112" y="1682496"/>
-            <a:ext cx="4773168" cy="292608"/>
-          </a:xfrm>
-          <a:prstGeom prst="rect">
-            <a:avLst/>
-          </a:prstGeom>
-          <a:noFill/>
-          <a:ln/>
-        </p:spPr>
-        <p:txBody>
-          <a:bodyPr wrap="square" rtlCol="0" anchor="ctr"/>
-          <a:lstStyle/>
-          <a:p>
-            <a:pPr indent="0" marL="0">
-              <a:buNone/>
-            </a:pPr>
-            <a:r>
-              <a:rPr lang="en-US" sz="1450" b="1" dirty="0">
-                <a:solidFill>
-                  <a:srgbClr val="1A1A2E"/>
-                </a:solidFill>
-                <a:latin typeface="Segoe UI" pitchFamily="34" charset="0"/>
-                <a:ea typeface="Segoe UI" pitchFamily="34" charset="-122"/>
-                <a:cs typeface="Segoe UI" pitchFamily="34" charset="-120"/>
-              </a:rPr>
-              <a:t>AGM Response</a:t>
-            </a:r>
-            <a:endParaRPr lang="en-US" sz="1450" dirty="0"/>
-          </a:p>
-        </p:txBody>
-      </p:sp>
-      <p:sp>
-        <p:nvSpPr>
-          <p:cNvPr id="8" name="Text 6"/>
-          <p:cNvSpPr/>
-          <p:nvPr/>
-        </p:nvSpPr>
-        <p:spPr>
-          <a:xfrm>
-            <a:off x="896112" y="1975104"/>
-            <a:ext cx="4773168" cy="566928"/>
-          </a:xfrm>
-          <a:prstGeom prst="rect">
-            <a:avLst/>
-          </a:prstGeom>
-          <a:noFill/>
-          <a:ln/>
-        </p:spPr>
-        <p:txBody>
-          <a:bodyPr wrap="square" rtlCol="0" anchor="ctr"/>
-          <a:lstStyle/>
-          <a:p>
-            <a:pPr indent="0" marL="0">
-              <a:lnSpc>
-                <a:spcPct val="115000"/>
-              </a:lnSpc>
-              <a:buNone/>
-            </a:pPr>
-            <a:r>
-              <a:rPr lang="en-US" sz="1150" dirty="0">
-                <a:solidFill>
-                  <a:srgbClr val="475569"/>
-                </a:solidFill>
-                <a:latin typeface="Segoe UI" pitchFamily="34" charset="0"/>
-                <a:ea typeface="Segoe UI" pitchFamily="34" charset="-122"/>
-                <a:cs typeface="Segoe UI" pitchFamily="34" charset="-120"/>
-              </a:rPr>
-              <a:t>Assigns the ticket to someone and commits a target date.</a:t>
-            </a:r>
-            <a:endParaRPr lang="en-US" sz="1150" dirty="0"/>
-          </a:p>
-        </p:txBody>
-      </p:sp>
-      <p:sp>
-        <p:nvSpPr>
-          <p:cNvPr id="9" name="Shape 7"/>
-          <p:cNvSpPr/>
-          <p:nvPr/>
-        </p:nvSpPr>
-        <p:spPr>
-          <a:xfrm>
-            <a:off x="640080" y="2752344"/>
-            <a:ext cx="82296" cy="82296"/>
-          </a:xfrm>
-          <a:prstGeom prst="rect">
-            <a:avLst/>
-          </a:prstGeom>
-          <a:solidFill>
-            <a:srgbClr val="7C3AED"/>
-          </a:solidFill>
-          <a:ln/>
-        </p:spPr>
-      </p:sp>
-      <p:sp>
-        <p:nvSpPr>
-          <p:cNvPr id="10" name="Text 8"/>
-          <p:cNvSpPr/>
-          <p:nvPr/>
-        </p:nvSpPr>
-        <p:spPr>
-          <a:xfrm>
-            <a:off x="896112" y="2615184"/>
-            <a:ext cx="4773168" cy="292608"/>
-          </a:xfrm>
-          <a:prstGeom prst="rect">
-            <a:avLst/>
-          </a:prstGeom>
-          <a:noFill/>
-          <a:ln/>
-        </p:spPr>
-        <p:txBody>
-          <a:bodyPr wrap="square" rtlCol="0" anchor="ctr"/>
-          <a:lstStyle/>
-          <a:p>
-            <a:pPr indent="0" marL="0">
-              <a:buNone/>
-            </a:pPr>
-            <a:r>
-              <a:rPr lang="en-US" sz="1450" b="1" dirty="0">
-                <a:solidFill>
-                  <a:srgbClr val="1A1A2E"/>
-                </a:solidFill>
-                <a:latin typeface="Segoe UI" pitchFamily="34" charset="0"/>
-                <a:ea typeface="Segoe UI" pitchFamily="34" charset="-122"/>
-                <a:cs typeface="Segoe UI" pitchFamily="34" charset="-120"/>
-              </a:rPr>
-              <a:t>GM — Priority</a:t>
-            </a:r>
-            <a:endParaRPr lang="en-US" sz="1450" dirty="0"/>
-          </a:p>
-        </p:txBody>
-      </p:sp>
-      <p:sp>
-        <p:nvSpPr>
-          <p:cNvPr id="11" name="Text 9"/>
-          <p:cNvSpPr/>
-          <p:nvPr/>
-        </p:nvSpPr>
-        <p:spPr>
-          <a:xfrm>
-            <a:off x="896112" y="2907792"/>
-            <a:ext cx="4773168" cy="566928"/>
-          </a:xfrm>
-          <a:prstGeom prst="rect">
-            <a:avLst/>
-          </a:prstGeom>
-          <a:noFill/>
-          <a:ln/>
-        </p:spPr>
-        <p:txBody>
-          <a:bodyPr wrap="square" rtlCol="0" anchor="ctr"/>
-          <a:lstStyle/>
-          <a:p>
-            <a:pPr indent="0" marL="0">
-              <a:lnSpc>
-                <a:spcPct val="115000"/>
-              </a:lnSpc>
-              <a:buNone/>
-            </a:pPr>
-            <a:r>
-              <a:rPr lang="en-US" sz="1150" dirty="0">
-                <a:solidFill>
-                  <a:srgbClr val="475569"/>
-                </a:solidFill>
-                <a:latin typeface="Segoe UI" pitchFamily="34" charset="0"/>
-                <a:ea typeface="Segoe UI" pitchFamily="34" charset="-122"/>
-                <a:cs typeface="Segoe UI" pitchFamily="34" charset="-120"/>
-              </a:rPr>
-              <a:t>Sets how urgently it needs to move.</a:t>
-            </a:r>
-            <a:endParaRPr lang="en-US" sz="1150" dirty="0"/>
-          </a:p>
-        </p:txBody>
-      </p:sp>
-      <p:sp>
-        <p:nvSpPr>
-          <p:cNvPr id="12" name="Shape 10"/>
-          <p:cNvSpPr/>
-          <p:nvPr/>
-        </p:nvSpPr>
-        <p:spPr>
-          <a:xfrm>
-            <a:off x="640080" y="3685032"/>
-            <a:ext cx="82296" cy="82296"/>
-          </a:xfrm>
-          <a:prstGeom prst="rect">
-            <a:avLst/>
-          </a:prstGeom>
-          <a:solidFill>
-            <a:srgbClr val="7C3AED"/>
-          </a:solidFill>
-          <a:ln/>
-        </p:spPr>
-      </p:sp>
-      <p:sp>
-        <p:nvSpPr>
-          <p:cNvPr id="13" name="Text 11"/>
-          <p:cNvSpPr/>
-          <p:nvPr/>
-        </p:nvSpPr>
-        <p:spPr>
-          <a:xfrm>
-            <a:off x="896112" y="3547872"/>
-            <a:ext cx="4773168" cy="292608"/>
-          </a:xfrm>
-          <a:prstGeom prst="rect">
-            <a:avLst/>
-          </a:prstGeom>
-          <a:noFill/>
-          <a:ln/>
-        </p:spPr>
-        <p:txBody>
-          <a:bodyPr wrap="square" rtlCol="0" anchor="ctr"/>
-          <a:lstStyle/>
-          <a:p>
-            <a:pPr indent="0" marL="0">
-              <a:buNone/>
-            </a:pPr>
-            <a:r>
-              <a:rPr lang="en-US" sz="1450" b="1" dirty="0">
-                <a:solidFill>
-                  <a:srgbClr val="1A1A2E"/>
-                </a:solidFill>
-                <a:latin typeface="Segoe UI" pitchFamily="34" charset="0"/>
-                <a:ea typeface="Segoe UI" pitchFamily="34" charset="-122"/>
-                <a:cs typeface="Segoe UI" pitchFamily="34" charset="-120"/>
-              </a:rPr>
-              <a:t>Planning — Status</a:t>
-            </a:r>
-            <a:endParaRPr lang="en-US" sz="1450" dirty="0"/>
-          </a:p>
-        </p:txBody>
-      </p:sp>
-      <p:sp>
-        <p:nvSpPr>
-          <p:cNvPr id="14" name="Text 12"/>
-          <p:cNvSpPr/>
-          <p:nvPr/>
-        </p:nvSpPr>
-        <p:spPr>
-          <a:xfrm>
-            <a:off x="896112" y="3840480"/>
-            <a:ext cx="4773168" cy="566928"/>
-          </a:xfrm>
-          <a:prstGeom prst="rect">
-            <a:avLst/>
-          </a:prstGeom>
-          <a:noFill/>
-          <a:ln/>
-        </p:spPr>
-        <p:txBody>
-          <a:bodyPr wrap="square" rtlCol="0" anchor="ctr"/>
-          <a:lstStyle/>
-          <a:p>
-            <a:pPr indent="0" marL="0">
-              <a:lnSpc>
-                <a:spcPct val="115000"/>
-              </a:lnSpc>
-              <a:buNone/>
-            </a:pPr>
-            <a:r>
-              <a:rPr lang="en-US" sz="1150" dirty="0">
-                <a:solidFill>
-                  <a:srgbClr val="475569"/>
-                </a:solidFill>
-                <a:latin typeface="Segoe UI" pitchFamily="34" charset="0"/>
-                <a:ea typeface="Segoe UI" pitchFamily="34" charset="-122"/>
-                <a:cs typeface="Segoe UI" pitchFamily="34" charset="-120"/>
-              </a:rPr>
-              <a:t>Updates progress through to an actual completion date.</a:t>
-            </a:r>
-            <a:endParaRPr lang="en-US" sz="1150" dirty="0"/>
-          </a:p>
-        </p:txBody>
-      </p:sp>
-      <p:sp>
-        <p:nvSpPr>
-          <p:cNvPr id="15" name="Shape 13"/>
-          <p:cNvSpPr/>
-          <p:nvPr/>
-        </p:nvSpPr>
-        <p:spPr>
-          <a:xfrm>
-            <a:off x="640080" y="4617720"/>
-            <a:ext cx="82296" cy="82296"/>
-          </a:xfrm>
-          <a:prstGeom prst="rect">
-            <a:avLst/>
-          </a:prstGeom>
-          <a:solidFill>
-            <a:srgbClr val="7C3AED"/>
-          </a:solidFill>
-          <a:ln/>
-        </p:spPr>
-      </p:sp>
-      <p:sp>
-        <p:nvSpPr>
-          <p:cNvPr id="16" name="Text 14"/>
-          <p:cNvSpPr/>
-          <p:nvPr/>
-        </p:nvSpPr>
-        <p:spPr>
-          <a:xfrm>
-            <a:off x="896112" y="4480560"/>
-            <a:ext cx="4773168" cy="292608"/>
-          </a:xfrm>
-          <a:prstGeom prst="rect">
-            <a:avLst/>
-          </a:prstGeom>
-          <a:noFill/>
-          <a:ln/>
-        </p:spPr>
-        <p:txBody>
-          <a:bodyPr wrap="square" rtlCol="0" anchor="ctr"/>
-          <a:lstStyle/>
-          <a:p>
-            <a:pPr indent="0" marL="0">
-              <a:buNone/>
-            </a:pPr>
-            <a:r>
-              <a:rPr lang="en-US" sz="1450" b="1" dirty="0">
-                <a:solidFill>
-                  <a:srgbClr val="1A1A2E"/>
-                </a:solidFill>
-                <a:latin typeface="Segoe UI" pitchFamily="34" charset="0"/>
-                <a:ea typeface="Segoe UI" pitchFamily="34" charset="-122"/>
-                <a:cs typeface="Segoe UI" pitchFamily="34" charset="-120"/>
-              </a:rPr>
-              <a:t>Verification</a:t>
-            </a:r>
-            <a:endParaRPr lang="en-US" sz="1450" dirty="0"/>
-          </a:p>
-        </p:txBody>
-      </p:sp>
-      <p:sp>
-        <p:nvSpPr>
-          <p:cNvPr id="17" name="Text 15"/>
-          <p:cNvSpPr/>
-          <p:nvPr/>
-        </p:nvSpPr>
-        <p:spPr>
-          <a:xfrm>
-            <a:off x="896112" y="4773168"/>
-            <a:ext cx="4773168" cy="566928"/>
-          </a:xfrm>
-          <a:prstGeom prst="rect">
-            <a:avLst/>
-          </a:prstGeom>
-          <a:noFill/>
-          <a:ln/>
-        </p:spPr>
-        <p:txBody>
-          <a:bodyPr wrap="square" rtlCol="0" anchor="ctr"/>
-          <a:lstStyle/>
-          <a:p>
-            <a:pPr indent="0" marL="0">
-              <a:lnSpc>
-                <a:spcPct val="115000"/>
-              </a:lnSpc>
-              <a:buNone/>
-            </a:pPr>
-            <a:r>
-              <a:rPr lang="en-US" sz="1150" dirty="0">
-                <a:solidFill>
-                  <a:srgbClr val="475569"/>
-                </a:solidFill>
-                <a:latin typeface="Segoe UI" pitchFamily="34" charset="0"/>
-                <a:ea typeface="Segoe UI" pitchFamily="34" charset="-122"/>
-                <a:cs typeface="Segoe UI" pitchFamily="34" charset="-120"/>
-              </a:rPr>
-              <a:t>Planning and the project team both confirm it's genuinely resolved.</a:t>
-            </a:r>
-            <a:endParaRPr lang="en-US" sz="1150" dirty="0"/>
-          </a:p>
-        </p:txBody>
-      </p:sp>
-      <p:pic>
-        <p:nvPicPr>
-          <p:cNvPr id="18" name="Image 0" descr="shots/16_drawing_request_edit_modal.png">    </p:cNvPr>
-          <p:cNvPicPr>
-            <a:picLocks noChangeAspect="1"/>
-          </p:cNvPicPr>
-          <p:nvPr/>
-        </p:nvPicPr>
-        <p:blipFill>
-          <a:blip r:embed="rId1"/>
-          <a:stretch>
-            <a:fillRect/>
-          </a:stretch>
-        </p:blipFill>
-        <p:spPr>
-          <a:xfrm>
-            <a:off x="5989320" y="1600200"/>
-            <a:ext cx="5669280" cy="4663440"/>
-          </a:xfrm>
-          <a:prstGeom prst="rect">
-            <a:avLst/>
-          </a:prstGeom>
-          <a:effectLst>
-            <a:outerShdw sx="100000" sy="100000" kx="0" ky="0" algn="bl" rotWithShape="0" blurRad="228600" dist="76200" dir="5400000">
-              <a:srgbClr val="1A1A2E">
-                <a:alpha val="35000"/>
-              </a:srgbClr>
-            </a:outerShdw>
-          </a:effectLst>
-        </p:spPr>
-      </p:pic>
-      <p:sp>
-        <p:nvSpPr>
-          <p:cNvPr id="19" name="Text 16"/>
-          <p:cNvSpPr/>
-          <p:nvPr/>
-        </p:nvSpPr>
-        <p:spPr>
-          <a:xfrm>
-            <a:off x="457200" y="6547104"/>
-            <a:ext cx="5486400" cy="274320"/>
-          </a:xfrm>
-          <a:prstGeom prst="rect">
-            <a:avLst/>
-          </a:prstGeom>
-          <a:noFill/>
-          <a:ln/>
-        </p:spPr>
-        <p:txBody>
-          <a:bodyPr wrap="square" rtlCol="0" anchor="ctr"/>
-          <a:lstStyle/>
-          <a:p>
-            <a:pPr indent="0" marL="0">
-              <a:buNone/>
-            </a:pPr>
-            <a:r>
-              <a:rPr lang="en-US" sz="900" dirty="0">
-                <a:solidFill>
-                  <a:srgbClr val="94A3B8"/>
-                </a:solidFill>
-                <a:latin typeface="Segoe UI" pitchFamily="34" charset="0"/>
-                <a:ea typeface="Segoe UI" pitchFamily="34" charset="-122"/>
-                <a:cs typeface="Segoe UI" pitchFamily="34" charset="-120"/>
-              </a:rPr>
-              <a:t>Nexora ERP  ·  DRI Dashboard Overview</a:t>
-            </a:r>
-            <a:endParaRPr lang="en-US" sz="900" dirty="0"/>
-          </a:p>
-        </p:txBody>
-      </p:sp>
-      <p:sp>
-        <p:nvSpPr>
-          <p:cNvPr id="20" name="Text 17"/>
-          <p:cNvSpPr/>
-          <p:nvPr/>
-        </p:nvSpPr>
-        <p:spPr>
-          <a:xfrm>
-            <a:off x="11521440" y="6547104"/>
-            <a:ext cx="365760" cy="274320"/>
-          </a:xfrm>
-          <a:prstGeom prst="rect">
-            <a:avLst/>
-          </a:prstGeom>
-          <a:noFill/>
-          <a:ln/>
-        </p:spPr>
-        <p:txBody>
-          <a:bodyPr wrap="square" rtlCol="0" anchor="ctr"/>
-          <a:lstStyle/>
-          <a:p>
-            <a:pPr algn="r" indent="0" marL="0">
-              <a:buNone/>
-            </a:pPr>
-            <a:r>
-              <a:rPr lang="en-US" sz="900" dirty="0">
-                <a:solidFill>
-                  <a:srgbClr val="94A3B8"/>
-                </a:solidFill>
-                <a:latin typeface="Segoe UI" pitchFamily="34" charset="0"/>
-                <a:ea typeface="Segoe UI" pitchFamily="34" charset="-122"/>
-                <a:cs typeface="Segoe UI" pitchFamily="34" charset="-120"/>
-              </a:rPr>
-              <a:t>13</a:t>
-            </a:r>
-            <a:endParaRPr lang="en-US" sz="900" dirty="0"/>
-          </a:p>
-        </p:txBody>
-      </p:sp>
-    </p:spTree>
-  </p:cSld>
-  <p:clrMapOvr>
-    <a:masterClrMapping/>
-  </p:clrMapOvr>
-</p:sld>
-</file>
-
-<file path=ppt/slides/slide14.xml><?xml version="1.0" encoding="utf-8"?>
-<p:sld xmlns:a="http://schemas.openxmlformats.org/drawingml/2006/main" xmlns:r="http://schemas.openxmlformats.org/officeDocument/2006/relationships" xmlns:p="http://schemas.openxmlformats.org/presentationml/2006/main">
-  <p:cSld name="Slide 14">
     <p:bg>
       <p:bgPr>
         <a:solidFill>
@@ -4604,7 +3527,7 @@
                 <a:ea typeface="Segoe UI" pitchFamily="34" charset="-122"/>
                 <a:cs typeface="Segoe UI" pitchFamily="34" charset="-120"/>
               </a:rPr>
-              <a:t>One dashboard, three connected workflows</a:t>
+              <a:t>One dashboard, two connected workflows</a:t>
             </a:r>
             <a:endParaRPr lang="en-US" sz="3400" dirty="0"/>
           </a:p>
@@ -4646,7 +3569,7 @@
                 <a:ea typeface="Segoe UI" pitchFamily="34" charset="-122"/>
                 <a:cs typeface="Segoe UI" pitchFamily="34" charset="-120"/>
               </a:rPr>
-              <a:t>Project Wise Progress feeds billing. Daily Progress Reports build the site's photographic record. Drawing Requests keep Planning and the site in sync.</a:t>
+              <a:t>Daily Progress Reports build the site's photographic record. Drawing Requests keep Planning and the site in sync.</a:t>
             </a:r>
             <a:endParaRPr lang="en-US" sz="1500" dirty="0"/>
           </a:p>
@@ -4763,7 +3686,7 @@
                 <a:ea typeface="Segoe UI" pitchFamily="34" charset="-122"/>
                 <a:cs typeface="Segoe UI" pitchFamily="34" charset="-120"/>
               </a:rPr>
-              <a:t>14</a:t>
+              <a:t>10</a:t>
             </a:r>
             <a:endParaRPr lang="en-US" sz="900" dirty="0"/>
           </a:p>
@@ -4873,7 +3796,7 @@
                 <a:ea typeface="Segoe UI" pitchFamily="34" charset="-122"/>
                 <a:cs typeface="Segoe UI" pitchFamily="34" charset="-120"/>
               </a:rPr>
-              <a:t>Three connected workflows a Site DRI uses every day</a:t>
+              <a:t>Two connected workflows a Site DRI uses every day</a:t>
             </a:r>
             <a:endParaRPr lang="en-US" sz="1400" dirty="0"/>
           </a:p>
@@ -4887,12 +3810,12 @@
         </p:nvSpPr>
         <p:spPr>
           <a:xfrm>
-            <a:off x="731520" y="1737360"/>
-            <a:ext cx="3429000" cy="4297680"/>
+            <a:off x="704088" y="1737360"/>
+            <a:ext cx="5120640" cy="4297680"/>
           </a:xfrm>
           <a:prstGeom prst="roundRect">
             <a:avLst>
-              <a:gd name="adj" fmla="val 3200"/>
+              <a:gd name="adj" fmla="val 2553"/>
             </a:avLst>
           </a:prstGeom>
           <a:solidFill>
@@ -4921,14 +3844,14 @@
         </p:nvSpPr>
         <p:spPr>
           <a:xfrm>
-            <a:off x="731520" y="1737360"/>
-            <a:ext cx="3429000" cy="128016"/>
+            <a:off x="704088" y="1737360"/>
+            <a:ext cx="5120640" cy="128016"/>
           </a:xfrm>
           <a:prstGeom prst="rect">
             <a:avLst/>
           </a:prstGeom>
           <a:solidFill>
-            <a:srgbClr val="FF7A00"/>
+            <a:srgbClr val="4F46E5"/>
           </a:solidFill>
           <a:ln/>
         </p:spPr>
@@ -4941,7 +3864,7 @@
         </p:nvSpPr>
         <p:spPr>
           <a:xfrm>
-            <a:off x="1051560" y="2057400"/>
+            <a:off x="1024128" y="2057400"/>
             <a:ext cx="1828800" cy="640080"/>
           </a:xfrm>
           <a:prstGeom prst="rect">
@@ -4960,7 +3883,7 @@
             <a:r>
               <a:rPr lang="en-US" sz="3400" b="1" dirty="0">
                 <a:solidFill>
-                  <a:srgbClr val="FF7A00">
+                  <a:srgbClr val="4F46E5">
                     <a:alpha val="75000"/>
                   </a:srgbClr>
                 </a:solidFill>
@@ -4982,8 +3905,8 @@
         </p:nvSpPr>
         <p:spPr>
           <a:xfrm>
-            <a:off x="1051560" y="2788920"/>
-            <a:ext cx="2788920" cy="685800"/>
+            <a:off x="1024128" y="2788920"/>
+            <a:ext cx="4480560" cy="685800"/>
           </a:xfrm>
           <a:prstGeom prst="rect">
             <a:avLst/>
@@ -5007,7 +3930,7 @@
                 <a:ea typeface="Segoe UI" pitchFamily="34" charset="-122"/>
                 <a:cs typeface="Segoe UI" pitchFamily="34" charset="-120"/>
               </a:rPr>
-              <a:t>Project Wise Progress</a:t>
+              <a:t>Daily Progress Report</a:t>
             </a:r>
             <a:endParaRPr lang="en-US" sz="1800" dirty="0"/>
           </a:p>
@@ -5021,8 +3944,8 @@
         </p:nvSpPr>
         <p:spPr>
           <a:xfrm>
-            <a:off x="1051560" y="3429000"/>
-            <a:ext cx="2788920" cy="2286000"/>
+            <a:off x="1024128" y="3429000"/>
+            <a:ext cx="4480560" cy="2286000"/>
           </a:xfrm>
           <a:prstGeom prst="rect">
             <a:avLst/>
@@ -5049,7 +3972,7 @@
                 <a:ea typeface="Segoe UI" pitchFamily="34" charset="-122"/>
                 <a:cs typeface="Segoe UI" pitchFamily="34" charset="-120"/>
               </a:rPr>
-              <a:t>Pick a project, log today's measured quantity against each scope item, and watch billing-ready progress build up automatically.</a:t>
+              <a:t>One end-of-day form: project, contractor, shift, labour count, and a work-type checklist backed by photo evidence.</a:t>
             </a:r>
             <a:endParaRPr lang="en-US" sz="1200" dirty="0"/>
           </a:p>
@@ -5063,12 +3986,12 @@
         </p:nvSpPr>
         <p:spPr>
           <a:xfrm>
-            <a:off x="4480560" y="1737360"/>
-            <a:ext cx="3429000" cy="4297680"/>
+            <a:off x="6373368" y="1737360"/>
+            <a:ext cx="5120640" cy="4297680"/>
           </a:xfrm>
           <a:prstGeom prst="roundRect">
             <a:avLst>
-              <a:gd name="adj" fmla="val 3200"/>
+              <a:gd name="adj" fmla="val 2553"/>
             </a:avLst>
           </a:prstGeom>
           <a:solidFill>
@@ -5097,14 +4020,14 @@
         </p:nvSpPr>
         <p:spPr>
           <a:xfrm>
-            <a:off x="4480560" y="1737360"/>
-            <a:ext cx="3429000" cy="128016"/>
+            <a:off x="6373368" y="1737360"/>
+            <a:ext cx="5120640" cy="128016"/>
           </a:xfrm>
           <a:prstGeom prst="rect">
             <a:avLst/>
           </a:prstGeom>
           <a:solidFill>
-            <a:srgbClr val="4F46E5"/>
+            <a:srgbClr val="7C3AED"/>
           </a:solidFill>
           <a:ln/>
         </p:spPr>
@@ -5117,7 +4040,7 @@
         </p:nvSpPr>
         <p:spPr>
           <a:xfrm>
-            <a:off x="4800600" y="2057400"/>
+            <a:off x="6693408" y="2057400"/>
             <a:ext cx="1828800" cy="640080"/>
           </a:xfrm>
           <a:prstGeom prst="rect">
@@ -5136,7 +4059,7 @@
             <a:r>
               <a:rPr lang="en-US" sz="3400" b="1" dirty="0">
                 <a:solidFill>
-                  <a:srgbClr val="4F46E5">
+                  <a:srgbClr val="7C3AED">
                     <a:alpha val="75000"/>
                   </a:srgbClr>
                 </a:solidFill>
@@ -5158,8 +4081,8 @@
         </p:nvSpPr>
         <p:spPr>
           <a:xfrm>
-            <a:off x="4800600" y="2788920"/>
-            <a:ext cx="2788920" cy="685800"/>
+            <a:off x="6693408" y="2788920"/>
+            <a:ext cx="4480560" cy="685800"/>
           </a:xfrm>
           <a:prstGeom prst="rect">
             <a:avLst/>
@@ -5183,7 +4106,7 @@
                 <a:ea typeface="Segoe UI" pitchFamily="34" charset="-122"/>
                 <a:cs typeface="Segoe UI" pitchFamily="34" charset="-120"/>
               </a:rPr>
-              <a:t>Daily Progress Report</a:t>
+              <a:t>Drawing Requests</a:t>
             </a:r>
             <a:endParaRPr lang="en-US" sz="1800" dirty="0"/>
           </a:p>
@@ -5197,8 +4120,8 @@
         </p:nvSpPr>
         <p:spPr>
           <a:xfrm>
-            <a:off x="4800600" y="3429000"/>
-            <a:ext cx="2788920" cy="2286000"/>
+            <a:off x="6693408" y="3429000"/>
+            <a:ext cx="4480560" cy="2286000"/>
           </a:xfrm>
           <a:prstGeom prst="rect">
             <a:avLst/>
@@ -5225,7 +4148,7 @@
                 <a:ea typeface="Segoe UI" pitchFamily="34" charset="-122"/>
                 <a:cs typeface="Segoe UI" pitchFamily="34" charset="-120"/>
               </a:rPr>
-              <a:t>One end-of-day form: project, contractor, shift, labour count, and a work-type checklist backed by photo evidence.</a:t>
+              <a:t>Raise a ticket for a missing drawing right from the report — then track it through AGM, GM, and Planning until it's resolved.</a:t>
             </a:r>
             <a:endParaRPr lang="en-US" sz="1200" dirty="0"/>
           </a:p>
@@ -5233,183 +4156,7 @@
       </p:sp>
       <p:sp>
         <p:nvSpPr>
-          <p:cNvPr id="14" name="Shape 12"/>
-          <p:cNvSpPr/>
-          <p:nvPr/>
-        </p:nvSpPr>
-        <p:spPr>
-          <a:xfrm>
-            <a:off x="8229600" y="1737360"/>
-            <a:ext cx="3429000" cy="4297680"/>
-          </a:xfrm>
-          <a:prstGeom prst="roundRect">
-            <a:avLst>
-              <a:gd name="adj" fmla="val 3200"/>
-            </a:avLst>
-          </a:prstGeom>
-          <a:solidFill>
-            <a:srgbClr val="FFFFFF"/>
-          </a:solidFill>
-          <a:ln w="12700">
-            <a:solidFill>
-              <a:srgbClr val="E5E7EB"/>
-            </a:solidFill>
-            <a:prstDash val="solid"/>
-          </a:ln>
-          <a:effectLst>
-            <a:outerShdw sx="100000" sy="100000" kx="0" ky="0" algn="bl" rotWithShape="0" blurRad="228600" dist="76200" dir="5400000">
-              <a:srgbClr val="1A1A2E">
-                <a:alpha val="35000"/>
-              </a:srgbClr>
-            </a:outerShdw>
-          </a:effectLst>
-        </p:spPr>
-      </p:sp>
-      <p:sp>
-        <p:nvSpPr>
-          <p:cNvPr id="15" name="Shape 13"/>
-          <p:cNvSpPr/>
-          <p:nvPr/>
-        </p:nvSpPr>
-        <p:spPr>
-          <a:xfrm>
-            <a:off x="8229600" y="1737360"/>
-            <a:ext cx="3429000" cy="128016"/>
-          </a:xfrm>
-          <a:prstGeom prst="rect">
-            <a:avLst/>
-          </a:prstGeom>
-          <a:solidFill>
-            <a:srgbClr val="7C3AED"/>
-          </a:solidFill>
-          <a:ln/>
-        </p:spPr>
-      </p:sp>
-      <p:sp>
-        <p:nvSpPr>
-          <p:cNvPr id="16" name="Text 14"/>
-          <p:cNvSpPr/>
-          <p:nvPr/>
-        </p:nvSpPr>
-        <p:spPr>
-          <a:xfrm>
-            <a:off x="8549640" y="2057400"/>
-            <a:ext cx="1828800" cy="640080"/>
-          </a:xfrm>
-          <a:prstGeom prst="rect">
-            <a:avLst/>
-          </a:prstGeom>
-          <a:noFill/>
-          <a:ln/>
-        </p:spPr>
-        <p:txBody>
-          <a:bodyPr wrap="square" rtlCol="0" anchor="ctr"/>
-          <a:lstStyle/>
-          <a:p>
-            <a:pPr indent="0" marL="0">
-              <a:buNone/>
-            </a:pPr>
-            <a:r>
-              <a:rPr lang="en-US" sz="3400" b="1" dirty="0">
-                <a:solidFill>
-                  <a:srgbClr val="7C3AED">
-                    <a:alpha val="75000"/>
-                  </a:srgbClr>
-                </a:solidFill>
-                <a:latin typeface="Segoe UI" pitchFamily="34" charset="0"/>
-                <a:ea typeface="Segoe UI" pitchFamily="34" charset="-122"/>
-                <a:cs typeface="Segoe UI" pitchFamily="34" charset="-120"/>
-              </a:rPr>
-              <a:t>03</a:t>
-            </a:r>
-            <a:endParaRPr lang="en-US" sz="3400" dirty="0"/>
-          </a:p>
-        </p:txBody>
-      </p:sp>
-      <p:sp>
-        <p:nvSpPr>
-          <p:cNvPr id="17" name="Text 15"/>
-          <p:cNvSpPr/>
-          <p:nvPr/>
-        </p:nvSpPr>
-        <p:spPr>
-          <a:xfrm>
-            <a:off x="8549640" y="2788920"/>
-            <a:ext cx="2788920" cy="685800"/>
-          </a:xfrm>
-          <a:prstGeom prst="rect">
-            <a:avLst/>
-          </a:prstGeom>
-          <a:noFill/>
-          <a:ln/>
-        </p:spPr>
-        <p:txBody>
-          <a:bodyPr wrap="square" rtlCol="0" anchor="ctr"/>
-          <a:lstStyle/>
-          <a:p>
-            <a:pPr indent="0" marL="0">
-              <a:buNone/>
-            </a:pPr>
-            <a:r>
-              <a:rPr lang="en-US" sz="1800" b="1" dirty="0">
-                <a:solidFill>
-                  <a:srgbClr val="1A1A2E"/>
-                </a:solidFill>
-                <a:latin typeface="Segoe UI" pitchFamily="34" charset="0"/>
-                <a:ea typeface="Segoe UI" pitchFamily="34" charset="-122"/>
-                <a:cs typeface="Segoe UI" pitchFamily="34" charset="-120"/>
-              </a:rPr>
-              <a:t>Drawing Requests</a:t>
-            </a:r>
-            <a:endParaRPr lang="en-US" sz="1800" dirty="0"/>
-          </a:p>
-        </p:txBody>
-      </p:sp>
-      <p:sp>
-        <p:nvSpPr>
-          <p:cNvPr id="18" name="Text 16"/>
-          <p:cNvSpPr/>
-          <p:nvPr/>
-        </p:nvSpPr>
-        <p:spPr>
-          <a:xfrm>
-            <a:off x="8549640" y="3429000"/>
-            <a:ext cx="2788920" cy="2286000"/>
-          </a:xfrm>
-          <a:prstGeom prst="rect">
-            <a:avLst/>
-          </a:prstGeom>
-          <a:noFill/>
-          <a:ln/>
-        </p:spPr>
-        <p:txBody>
-          <a:bodyPr wrap="square" rtlCol="0" anchor="ctr"/>
-          <a:lstStyle/>
-          <a:p>
-            <a:pPr indent="0" marL="0">
-              <a:lnSpc>
-                <a:spcPct val="125000"/>
-              </a:lnSpc>
-              <a:buNone/>
-            </a:pPr>
-            <a:r>
-              <a:rPr lang="en-US" sz="1200" dirty="0">
-                <a:solidFill>
-                  <a:srgbClr val="475569"/>
-                </a:solidFill>
-                <a:latin typeface="Segoe UI" pitchFamily="34" charset="0"/>
-                <a:ea typeface="Segoe UI" pitchFamily="34" charset="-122"/>
-                <a:cs typeface="Segoe UI" pitchFamily="34" charset="-120"/>
-              </a:rPr>
-              <a:t>Raise a ticket for a missing drawing right from the report — then track it through AGM, GM, and Planning until it's resolved.</a:t>
-            </a:r>
-            <a:endParaRPr lang="en-US" sz="1200" dirty="0"/>
-          </a:p>
-        </p:txBody>
-      </p:sp>
-      <p:sp>
-        <p:nvSpPr>
-          <p:cNvPr id="19" name="Text 17"/>
+          <p:cNvPr id="14" name="Text 12"/>
           <p:cNvSpPr/>
           <p:nvPr/>
         </p:nvSpPr>
@@ -5448,7 +4195,7 @@
       </p:sp>
       <p:sp>
         <p:nvSpPr>
-          <p:cNvPr id="20" name="Text 18"/>
+          <p:cNvPr id="15" name="Text 13"/>
           <p:cNvSpPr/>
           <p:nvPr/>
         </p:nvSpPr>
@@ -5499,7 +4246,7 @@
     <p:bg>
       <p:bgPr>
         <a:solidFill>
-          <a:srgbClr val="FF7A00"/>
+          <a:srgbClr val="4F46E5"/>
         </a:solidFill>
       </p:bgPr>
     </p:bg>
@@ -5611,7 +4358,7 @@
                 <a:ea typeface="Segoe UI" pitchFamily="34" charset="-122"/>
                 <a:cs typeface="Segoe UI" pitchFamily="34" charset="-120"/>
               </a:rPr>
-              <a:t>Project Wise Progress</a:t>
+              <a:t>Daily Progress Report</a:t>
             </a:r>
             <a:endParaRPr lang="en-US" sz="4000" dirty="0"/>
           </a:p>
@@ -5652,7 +4399,7 @@
                 <a:ea typeface="Segoe UI" pitchFamily="34" charset="-122"/>
                 <a:cs typeface="Segoe UI" pitchFamily="34" charset="-120"/>
               </a:rPr>
-              <a:t>Log today's measured quantity, project by project, scope item by scope item.</a:t>
+              <a:t>One end-of-day form — project, contractor, shift, labour, and photo-backed work-type checklist.</a:t>
             </a:r>
             <a:endParaRPr lang="en-US" sz="1500" dirty="0"/>
           </a:p>
@@ -5705,7 +4452,7 @@
             <a:avLst/>
           </a:prstGeom>
           <a:solidFill>
-            <a:srgbClr val="FF7A00"/>
+            <a:srgbClr val="4F46E5"/>
           </a:solidFill>
           <a:ln/>
         </p:spPr>
@@ -5763,7 +4510,7 @@
                 <a:ea typeface="Segoe UI" pitchFamily="34" charset="-122"/>
                 <a:cs typeface="Segoe UI" pitchFamily="34" charset="-120"/>
               </a:rPr>
-              <a:t>Project Wise Progress</a:t>
+              <a:t>Daily Progress Report — Overview</a:t>
             </a:r>
             <a:endParaRPr lang="en-US" sz="2400" dirty="0"/>
           </a:p>
@@ -5804,7 +4551,7 @@
                 <a:ea typeface="Segoe UI" pitchFamily="34" charset="-122"/>
                 <a:cs typeface="Segoe UI" pitchFamily="34" charset="-120"/>
               </a:rPr>
-              <a:t>Filter by project and category to pull up every work order that needs a measurement logged today.</a:t>
+              <a:t>Replaces two separate paper-style reports with a single, photo-verified daily submission.</a:t>
             </a:r>
             <a:endParaRPr lang="en-US" sz="1250" dirty="0"/>
           </a:p>
@@ -5825,7 +4572,7 @@
             <a:avLst/>
           </a:prstGeom>
           <a:solidFill>
-            <a:srgbClr val="FF7A00"/>
+            <a:srgbClr val="4F46E5"/>
           </a:solidFill>
           <a:ln/>
         </p:spPr>
@@ -5863,7 +4610,7 @@
                 <a:ea typeface="Segoe UI" pitchFamily="34" charset="-122"/>
                 <a:cs typeface="Segoe UI" pitchFamily="34" charset="-120"/>
               </a:rPr>
-              <a:t>Pick a project &amp; category</a:t>
+              <a:t>One submission per site day</a:t>
             </a:r>
             <a:endParaRPr lang="en-US" sz="1450" dirty="0"/>
           </a:p>
@@ -5905,7 +4652,7 @@
                 <a:ea typeface="Segoe UI" pitchFamily="34" charset="-122"/>
                 <a:cs typeface="Segoe UI" pitchFamily="34" charset="-120"/>
               </a:rPr>
-              <a:t>Filters narrow 200+ live work orders down to exactly what's relevant for today's site visit.</a:t>
+              <a:t>Project, DRI name, date, contractor, shift, and today's labour count — all in one place.</a:t>
             </a:r>
             <a:endParaRPr lang="en-US" sz="1150" dirty="0"/>
           </a:p>
@@ -5926,7 +4673,7 @@
             <a:avLst/>
           </a:prstGeom>
           <a:solidFill>
-            <a:srgbClr val="FF7A00"/>
+            <a:srgbClr val="4F46E5"/>
           </a:solidFill>
           <a:ln/>
         </p:spPr>
@@ -5964,7 +4711,7 @@
                 <a:ea typeface="Segoe UI" pitchFamily="34" charset="-122"/>
                 <a:cs typeface="Segoe UI" pitchFamily="34" charset="-120"/>
               </a:rPr>
-              <a:t>See what's outstanding</a:t>
+              <a:t>Every report is listed</a:t>
             </a:r>
             <a:endParaRPr lang="en-US" sz="1450" dirty="0"/>
           </a:p>
@@ -6006,7 +4753,7 @@
                 <a:ea typeface="Segoe UI" pitchFamily="34" charset="-122"/>
                 <a:cs typeface="Segoe UI" pitchFamily="34" charset="-120"/>
               </a:rPr>
-              <a:t>Each work order card shows the contractor, category, and current contract value at a glance.</a:t>
+              <a:t>The Recent Reports table shows what's been logged, by whom, and how many categories were covered.</a:t>
             </a:r>
             <a:endParaRPr lang="en-US" sz="1150" dirty="0"/>
           </a:p>
@@ -6027,7 +4774,7 @@
             <a:avLst/>
           </a:prstGeom>
           <a:solidFill>
-            <a:srgbClr val="FF7A00"/>
+            <a:srgbClr val="4F46E5"/>
           </a:solidFill>
           <a:ln/>
         </p:spPr>
@@ -6065,7 +4812,7 @@
                 <a:ea typeface="Segoe UI" pitchFamily="34" charset="-122"/>
                 <a:cs typeface="Segoe UI" pitchFamily="34" charset="-120"/>
               </a:rPr>
-              <a:t>Drill into scope items</a:t>
+              <a:t>Raise a Drawing Request inline</a:t>
             </a:r>
             <a:endParaRPr lang="en-US" sz="1450" dirty="0"/>
           </a:p>
@@ -6107,7 +4854,7 @@
                 <a:ea typeface="Segoe UI" pitchFamily="34" charset="-122"/>
                 <a:cs typeface="Segoe UI" pitchFamily="34" charset="-120"/>
               </a:rPr>
-              <a:t>Open a work order to see every scope item's Planned / Done / Billed / Unbilled quantities side by side.</a:t>
+              <a:t>A DRI who hits a missing drawing while filling this out can raise it without leaving the page.</a:t>
             </a:r>
             <a:endParaRPr lang="en-US" sz="1150" dirty="0"/>
           </a:p>
@@ -6128,7 +4875,7 @@
             <a:avLst/>
           </a:prstGeom>
           <a:solidFill>
-            <a:srgbClr val="FF7A00"/>
+            <a:srgbClr val="4F46E5"/>
           </a:solidFill>
           <a:ln/>
         </p:spPr>
@@ -6166,7 +4913,7 @@
                 <a:ea typeface="Segoe UI" pitchFamily="34" charset="-122"/>
                 <a:cs typeface="Segoe UI" pitchFamily="34" charset="-120"/>
               </a:rPr>
-              <a:t>Log a measurement</a:t>
+              <a:t>Available two ways</a:t>
             </a:r>
             <a:endParaRPr lang="en-US" sz="1450" dirty="0"/>
           </a:p>
@@ -6208,7 +4955,7 @@
                 <a:ea typeface="Segoe UI" pitchFamily="34" charset="-122"/>
                 <a:cs typeface="Segoe UI" pitchFamily="34" charset="-120"/>
               </a:rPr>
-              <a:t>"+ Measurement" records today's quantity against the right item — it rolls straight into billing readiness.</a:t>
+              <a:t>Inside the app for logged-in DRIs/Admins, and as a public no-login form for anyone on site.</a:t>
             </a:r>
             <a:endParaRPr lang="en-US" sz="1150" dirty="0"/>
           </a:p>
@@ -6216,7 +4963,7 @@
       </p:sp>
       <p:pic>
         <p:nvPicPr>
-          <p:cNvPr id="18" name="Image 0" descr="shots/02_progress_project_dashboard.png">    </p:cNvPr>
+          <p:cNvPr id="18" name="Image 0" descr="shots/09_dpr_submitted_list.png">    </p:cNvPr>
           <p:cNvPicPr>
             <a:picLocks noChangeAspect="1"/>
           </p:cNvPicPr>
@@ -6317,7 +5064,7 @@
                 <a:ea typeface="Segoe UI" pitchFamily="34" charset="-122"/>
                 <a:cs typeface="Segoe UI" pitchFamily="34" charset="-120"/>
               </a:rPr>
-              <a:t>4</a:t>
+              <a:t>3</a:t>
             </a:r>
             <a:endParaRPr lang="en-US" sz="900" dirty="0"/>
           </a:p>
@@ -6337,7 +5084,7 @@
     <p:bg>
       <p:bgPr>
         <a:solidFill>
-          <a:srgbClr val="4F46E5"/>
+          <a:srgbClr val="FFFFFF"/>
         </a:solidFill>
       </p:bgPr>
     </p:bg>
@@ -6357,44 +5104,23 @@
       </p:grpSpPr>
       <p:sp>
         <p:nvSpPr>
-          <p:cNvPr id="2" name="Text 0"/>
-          <p:cNvSpPr/>
-          <p:nvPr/>
-        </p:nvSpPr>
-        <p:spPr>
-          <a:xfrm>
-            <a:off x="822960" y="2011680"/>
-            <a:ext cx="2743200" cy="1463040"/>
-          </a:xfrm>
-          <a:prstGeom prst="rect">
-            <a:avLst/>
-          </a:prstGeom>
-          <a:noFill/>
-          <a:ln/>
-        </p:spPr>
-        <p:txBody>
-          <a:bodyPr wrap="square" rtlCol="0" anchor="ctr"/>
-          <a:lstStyle/>
-          <a:p>
-            <a:pPr indent="0" marL="0">
-              <a:buNone/>
-            </a:pPr>
-            <a:r>
-              <a:rPr lang="en-US" sz="9000" b="1" dirty="0">
-                <a:solidFill>
-                  <a:srgbClr val="FFFFFF">
-                    <a:alpha val="30000"/>
-                  </a:srgbClr>
-                </a:solidFill>
-                <a:latin typeface="Segoe UI" pitchFamily="34" charset="0"/>
-                <a:ea typeface="Segoe UI" pitchFamily="34" charset="-122"/>
-                <a:cs typeface="Segoe UI" pitchFamily="34" charset="-120"/>
-              </a:rPr>
-              <a:t>02</a:t>
-            </a:r>
-            <a:endParaRPr lang="en-US" sz="9000" dirty="0"/>
-          </a:p>
-        </p:txBody>
+          <p:cNvPr id="2" name="Shape 0"/>
+          <p:cNvSpPr/>
+          <p:nvPr/>
+        </p:nvSpPr>
+        <p:spPr>
+          <a:xfrm>
+            <a:off x="0" y="0"/>
+            <a:ext cx="12191695" cy="1234440"/>
+          </a:xfrm>
+          <a:prstGeom prst="rect">
+            <a:avLst/>
+          </a:prstGeom>
+          <a:solidFill>
+            <a:srgbClr val="4F46E5"/>
+          </a:solidFill>
+          <a:ln/>
+        </p:spPr>
       </p:sp>
       <p:sp>
         <p:nvSpPr>
@@ -6404,8 +5130,8 @@
         </p:nvSpPr>
         <p:spPr>
           <a:xfrm>
-            <a:off x="868680" y="3429000"/>
-            <a:ext cx="1280160" cy="64008"/>
+            <a:off x="502920" y="310896"/>
+            <a:ext cx="82296" cy="621792"/>
           </a:xfrm>
           <a:prstGeom prst="rect">
             <a:avLst/>
@@ -6424,24 +5150,24 @@
         </p:nvSpPr>
         <p:spPr>
           <a:xfrm>
-            <a:off x="822960" y="3611880"/>
-            <a:ext cx="10058400" cy="914400"/>
-          </a:xfrm>
-          <a:prstGeom prst="rect">
-            <a:avLst/>
-          </a:prstGeom>
-          <a:noFill/>
-          <a:ln/>
-        </p:spPr>
-        <p:txBody>
-          <a:bodyPr wrap="square" rtlCol="0" anchor="ctr"/>
-          <a:lstStyle/>
-          <a:p>
-            <a:pPr indent="0" marL="0">
-              <a:buNone/>
-            </a:pPr>
-            <a:r>
-              <a:rPr lang="en-US" sz="4000" b="1" dirty="0">
+            <a:off x="777240" y="237744"/>
+            <a:ext cx="9601200" cy="502920"/>
+          </a:xfrm>
+          <a:prstGeom prst="rect">
+            <a:avLst/>
+          </a:prstGeom>
+          <a:noFill/>
+          <a:ln/>
+        </p:spPr>
+        <p:txBody>
+          <a:bodyPr wrap="square" rtlCol="0" anchor="ctr"/>
+          <a:lstStyle/>
+          <a:p>
+            <a:pPr indent="0" marL="0">
+              <a:buNone/>
+            </a:pPr>
+            <a:r>
+              <a:rPr lang="en-US" sz="2400" b="1" dirty="0">
                 <a:solidFill>
                   <a:srgbClr val="FFFFFF"/>
                 </a:solidFill>
@@ -6449,9 +5175,9 @@
                 <a:ea typeface="Segoe UI" pitchFamily="34" charset="-122"/>
                 <a:cs typeface="Segoe UI" pitchFamily="34" charset="-120"/>
               </a:rPr>
-              <a:t>Daily Progress Report</a:t>
-            </a:r>
-            <a:endParaRPr lang="en-US" sz="4000" dirty="0"/>
+              <a:t>Filling In a Report</a:t>
+            </a:r>
+            <a:endParaRPr lang="en-US" sz="2400" dirty="0"/>
           </a:p>
         </p:txBody>
       </p:sp>
@@ -6463,24 +5189,24 @@
         </p:nvSpPr>
         <p:spPr>
           <a:xfrm>
-            <a:off x="822960" y="4434840"/>
-            <a:ext cx="9144000" cy="548640"/>
-          </a:xfrm>
-          <a:prstGeom prst="rect">
-            <a:avLst/>
-          </a:prstGeom>
-          <a:noFill/>
-          <a:ln/>
-        </p:spPr>
-        <p:txBody>
-          <a:bodyPr wrap="square" rtlCol="0" anchor="ctr"/>
-          <a:lstStyle/>
-          <a:p>
-            <a:pPr indent="0" marL="0">
-              <a:buNone/>
-            </a:pPr>
-            <a:r>
-              <a:rPr lang="en-US" sz="1500" dirty="0">
+            <a:off x="777240" y="713232"/>
+            <a:ext cx="10515600" cy="365760"/>
+          </a:xfrm>
+          <a:prstGeom prst="rect">
+            <a:avLst/>
+          </a:prstGeom>
+          <a:noFill/>
+          <a:ln/>
+        </p:spPr>
+        <p:txBody>
+          <a:bodyPr wrap="square" rtlCol="0" anchor="ctr"/>
+          <a:lstStyle/>
+          <a:p>
+            <a:pPr indent="0" marL="0">
+              <a:buNone/>
+            </a:pPr>
+            <a:r>
+              <a:rPr lang="en-US" sz="1250" dirty="0">
                 <a:solidFill>
                   <a:srgbClr val="FFFFFF">
                     <a:alpha val="85000"/>
@@ -6490,9 +5216,522 @@
                 <a:ea typeface="Segoe UI" pitchFamily="34" charset="-122"/>
                 <a:cs typeface="Segoe UI" pitchFamily="34" charset="-120"/>
               </a:rPr>
-              <a:t>One end-of-day form — project, contractor, shift, labour, and photo-backed work-type checklist.</a:t>
-            </a:r>
-            <a:endParaRPr lang="en-US" sz="1500" dirty="0"/>
+              <a:t>Report Details up top, the work-type checklist below — both in one wide, well-spaced drawer.</a:t>
+            </a:r>
+            <a:endParaRPr lang="en-US" sz="1250" dirty="0"/>
+          </a:p>
+        </p:txBody>
+      </p:sp>
+      <p:sp>
+        <p:nvSpPr>
+          <p:cNvPr id="6" name="Shape 4"/>
+          <p:cNvSpPr/>
+          <p:nvPr/>
+        </p:nvSpPr>
+        <p:spPr>
+          <a:xfrm>
+            <a:off x="640080" y="1819656"/>
+            <a:ext cx="82296" cy="82296"/>
+          </a:xfrm>
+          <a:prstGeom prst="rect">
+            <a:avLst/>
+          </a:prstGeom>
+          <a:solidFill>
+            <a:srgbClr val="4F46E5"/>
+          </a:solidFill>
+          <a:ln/>
+        </p:spPr>
+      </p:sp>
+      <p:sp>
+        <p:nvSpPr>
+          <p:cNvPr id="7" name="Text 5"/>
+          <p:cNvSpPr/>
+          <p:nvPr/>
+        </p:nvSpPr>
+        <p:spPr>
+          <a:xfrm>
+            <a:off x="896112" y="1682496"/>
+            <a:ext cx="4773168" cy="292608"/>
+          </a:xfrm>
+          <a:prstGeom prst="rect">
+            <a:avLst/>
+          </a:prstGeom>
+          <a:noFill/>
+          <a:ln/>
+        </p:spPr>
+        <p:txBody>
+          <a:bodyPr wrap="square" rtlCol="0" anchor="ctr"/>
+          <a:lstStyle/>
+          <a:p>
+            <a:pPr indent="0" marL="0">
+              <a:buNone/>
+            </a:pPr>
+            <a:r>
+              <a:rPr lang="en-US" sz="1450" b="1" dirty="0">
+                <a:solidFill>
+                  <a:srgbClr val="1A1A2E"/>
+                </a:solidFill>
+                <a:latin typeface="Segoe UI" pitchFamily="34" charset="0"/>
+                <a:ea typeface="Segoe UI" pitchFamily="34" charset="-122"/>
+                <a:cs typeface="Segoe UI" pitchFamily="34" charset="-120"/>
+              </a:rPr>
+              <a:t>Project &amp; Contractor</a:t>
+            </a:r>
+            <a:endParaRPr lang="en-US" sz="1450" dirty="0"/>
+          </a:p>
+        </p:txBody>
+      </p:sp>
+      <p:sp>
+        <p:nvSpPr>
+          <p:cNvPr id="8" name="Text 6"/>
+          <p:cNvSpPr/>
+          <p:nvPr/>
+        </p:nvSpPr>
+        <p:spPr>
+          <a:xfrm>
+            <a:off x="896112" y="1975104"/>
+            <a:ext cx="4773168" cy="566928"/>
+          </a:xfrm>
+          <a:prstGeom prst="rect">
+            <a:avLst/>
+          </a:prstGeom>
+          <a:noFill/>
+          <a:ln/>
+        </p:spPr>
+        <p:txBody>
+          <a:bodyPr wrap="square" rtlCol="0" anchor="ctr"/>
+          <a:lstStyle/>
+          <a:p>
+            <a:pPr indent="0" marL="0">
+              <a:lnSpc>
+                <a:spcPct val="115000"/>
+              </a:lnSpc>
+              <a:buNone/>
+            </a:pPr>
+            <a:r>
+              <a:rPr lang="en-US" sz="1150" dirty="0">
+                <a:solidFill>
+                  <a:srgbClr val="475569"/>
+                </a:solidFill>
+                <a:latin typeface="Segoe UI" pitchFamily="34" charset="0"/>
+                <a:ea typeface="Segoe UI" pitchFamily="34" charset="-122"/>
+                <a:cs typeface="Segoe UI" pitchFamily="34" charset="-120"/>
+              </a:rPr>
+              <a:t>Searchable dropdowns pull from the same live Projects and Contractors lists used across the app.</a:t>
+            </a:r>
+            <a:endParaRPr lang="en-US" sz="1150" dirty="0"/>
+          </a:p>
+        </p:txBody>
+      </p:sp>
+      <p:sp>
+        <p:nvSpPr>
+          <p:cNvPr id="9" name="Shape 7"/>
+          <p:cNvSpPr/>
+          <p:nvPr/>
+        </p:nvSpPr>
+        <p:spPr>
+          <a:xfrm>
+            <a:off x="640080" y="2752344"/>
+            <a:ext cx="82296" cy="82296"/>
+          </a:xfrm>
+          <a:prstGeom prst="rect">
+            <a:avLst/>
+          </a:prstGeom>
+          <a:solidFill>
+            <a:srgbClr val="4F46E5"/>
+          </a:solidFill>
+          <a:ln/>
+        </p:spPr>
+      </p:sp>
+      <p:sp>
+        <p:nvSpPr>
+          <p:cNvPr id="10" name="Text 8"/>
+          <p:cNvSpPr/>
+          <p:nvPr/>
+        </p:nvSpPr>
+        <p:spPr>
+          <a:xfrm>
+            <a:off x="896112" y="2615184"/>
+            <a:ext cx="4773168" cy="292608"/>
+          </a:xfrm>
+          <a:prstGeom prst="rect">
+            <a:avLst/>
+          </a:prstGeom>
+          <a:noFill/>
+          <a:ln/>
+        </p:spPr>
+        <p:txBody>
+          <a:bodyPr wrap="square" rtlCol="0" anchor="ctr"/>
+          <a:lstStyle/>
+          <a:p>
+            <a:pPr indent="0" marL="0">
+              <a:buNone/>
+            </a:pPr>
+            <a:r>
+              <a:rPr lang="en-US" sz="1450" b="1" dirty="0">
+                <a:solidFill>
+                  <a:srgbClr val="1A1A2E"/>
+                </a:solidFill>
+                <a:latin typeface="Segoe UI" pitchFamily="34" charset="0"/>
+                <a:ea typeface="Segoe UI" pitchFamily="34" charset="-122"/>
+                <a:cs typeface="Segoe UI" pitchFamily="34" charset="-120"/>
+              </a:rPr>
+              <a:t>DRI Name is a dropdown here</a:t>
+            </a:r>
+            <a:endParaRPr lang="en-US" sz="1450" dirty="0"/>
+          </a:p>
+        </p:txBody>
+      </p:sp>
+      <p:sp>
+        <p:nvSpPr>
+          <p:cNvPr id="11" name="Text 9"/>
+          <p:cNvSpPr/>
+          <p:nvPr/>
+        </p:nvSpPr>
+        <p:spPr>
+          <a:xfrm>
+            <a:off x="896112" y="2907792"/>
+            <a:ext cx="4773168" cy="566928"/>
+          </a:xfrm>
+          <a:prstGeom prst="rect">
+            <a:avLst/>
+          </a:prstGeom>
+          <a:noFill/>
+          <a:ln/>
+        </p:spPr>
+        <p:txBody>
+          <a:bodyPr wrap="square" rtlCol="0" anchor="ctr"/>
+          <a:lstStyle/>
+          <a:p>
+            <a:pPr indent="0" marL="0">
+              <a:lnSpc>
+                <a:spcPct val="115000"/>
+              </a:lnSpc>
+              <a:buNone/>
+            </a:pPr>
+            <a:r>
+              <a:rPr lang="en-US" sz="1150" dirty="0">
+                <a:solidFill>
+                  <a:srgbClr val="475569"/>
+                </a:solidFill>
+                <a:latin typeface="Segoe UI" pitchFamily="34" charset="0"/>
+                <a:ea typeface="Segoe UI" pitchFamily="34" charset="-122"/>
+                <a:cs typeface="Segoe UI" pitchFamily="34" charset="-120"/>
+              </a:rPr>
+              <a:t>Inside the app it's picked from registered site DRIs — the public form uses a free-text field instead.</a:t>
+            </a:r>
+            <a:endParaRPr lang="en-US" sz="1150" dirty="0"/>
+          </a:p>
+        </p:txBody>
+      </p:sp>
+      <p:sp>
+        <p:nvSpPr>
+          <p:cNvPr id="12" name="Shape 10"/>
+          <p:cNvSpPr/>
+          <p:nvPr/>
+        </p:nvSpPr>
+        <p:spPr>
+          <a:xfrm>
+            <a:off x="640080" y="3685032"/>
+            <a:ext cx="82296" cy="82296"/>
+          </a:xfrm>
+          <a:prstGeom prst="rect">
+            <a:avLst/>
+          </a:prstGeom>
+          <a:solidFill>
+            <a:srgbClr val="4F46E5"/>
+          </a:solidFill>
+          <a:ln/>
+        </p:spPr>
+      </p:sp>
+      <p:sp>
+        <p:nvSpPr>
+          <p:cNvPr id="13" name="Text 11"/>
+          <p:cNvSpPr/>
+          <p:nvPr/>
+        </p:nvSpPr>
+        <p:spPr>
+          <a:xfrm>
+            <a:off x="896112" y="3547872"/>
+            <a:ext cx="4773168" cy="292608"/>
+          </a:xfrm>
+          <a:prstGeom prst="rect">
+            <a:avLst/>
+          </a:prstGeom>
+          <a:noFill/>
+          <a:ln/>
+        </p:spPr>
+        <p:txBody>
+          <a:bodyPr wrap="square" rtlCol="0" anchor="ctr"/>
+          <a:lstStyle/>
+          <a:p>
+            <a:pPr indent="0" marL="0">
+              <a:buNone/>
+            </a:pPr>
+            <a:r>
+              <a:rPr lang="en-US" sz="1450" b="1" dirty="0">
+                <a:solidFill>
+                  <a:srgbClr val="1A1A2E"/>
+                </a:solidFill>
+                <a:latin typeface="Segoe UI" pitchFamily="34" charset="0"/>
+                <a:ea typeface="Segoe UI" pitchFamily="34" charset="-122"/>
+                <a:cs typeface="Segoe UI" pitchFamily="34" charset="-120"/>
+              </a:rPr>
+              <a:t>Shift &amp; labour count</a:t>
+            </a:r>
+            <a:endParaRPr lang="en-US" sz="1450" dirty="0"/>
+          </a:p>
+        </p:txBody>
+      </p:sp>
+      <p:sp>
+        <p:nvSpPr>
+          <p:cNvPr id="14" name="Text 12"/>
+          <p:cNvSpPr/>
+          <p:nvPr/>
+        </p:nvSpPr>
+        <p:spPr>
+          <a:xfrm>
+            <a:off x="896112" y="3840480"/>
+            <a:ext cx="4773168" cy="566928"/>
+          </a:xfrm>
+          <a:prstGeom prst="rect">
+            <a:avLst/>
+          </a:prstGeom>
+          <a:noFill/>
+          <a:ln/>
+        </p:spPr>
+        <p:txBody>
+          <a:bodyPr wrap="square" rtlCol="0" anchor="ctr"/>
+          <a:lstStyle/>
+          <a:p>
+            <a:pPr indent="0" marL="0">
+              <a:lnSpc>
+                <a:spcPct val="115000"/>
+              </a:lnSpc>
+              <a:buNone/>
+            </a:pPr>
+            <a:r>
+              <a:rPr lang="en-US" sz="1150" dirty="0">
+                <a:solidFill>
+                  <a:srgbClr val="475569"/>
+                </a:solidFill>
+                <a:latin typeface="Segoe UI" pitchFamily="34" charset="0"/>
+                <a:ea typeface="Segoe UI" pitchFamily="34" charset="-122"/>
+                <a:cs typeface="Segoe UI" pitchFamily="34" charset="-120"/>
+              </a:rPr>
+              <a:t>Day or Night shift, plus how many labourers were on site — quick to fill, nothing optional missed.</a:t>
+            </a:r>
+            <a:endParaRPr lang="en-US" sz="1150" dirty="0"/>
+          </a:p>
+        </p:txBody>
+      </p:sp>
+      <p:sp>
+        <p:nvSpPr>
+          <p:cNvPr id="15" name="Shape 13"/>
+          <p:cNvSpPr/>
+          <p:nvPr/>
+        </p:nvSpPr>
+        <p:spPr>
+          <a:xfrm>
+            <a:off x="640080" y="4617720"/>
+            <a:ext cx="82296" cy="82296"/>
+          </a:xfrm>
+          <a:prstGeom prst="rect">
+            <a:avLst/>
+          </a:prstGeom>
+          <a:solidFill>
+            <a:srgbClr val="4F46E5"/>
+          </a:solidFill>
+          <a:ln/>
+        </p:spPr>
+      </p:sp>
+      <p:sp>
+        <p:nvSpPr>
+          <p:cNvPr id="16" name="Text 14"/>
+          <p:cNvSpPr/>
+          <p:nvPr/>
+        </p:nvSpPr>
+        <p:spPr>
+          <a:xfrm>
+            <a:off x="896112" y="4480560"/>
+            <a:ext cx="4773168" cy="292608"/>
+          </a:xfrm>
+          <a:prstGeom prst="rect">
+            <a:avLst/>
+          </a:prstGeom>
+          <a:noFill/>
+          <a:ln/>
+        </p:spPr>
+        <p:txBody>
+          <a:bodyPr wrap="square" rtlCol="0" anchor="ctr"/>
+          <a:lstStyle/>
+          <a:p>
+            <a:pPr indent="0" marL="0">
+              <a:buNone/>
+            </a:pPr>
+            <a:r>
+              <a:rPr lang="en-US" sz="1450" b="1" dirty="0">
+                <a:solidFill>
+                  <a:srgbClr val="1A1A2E"/>
+                </a:solidFill>
+                <a:latin typeface="Segoe UI" pitchFamily="34" charset="0"/>
+                <a:ea typeface="Segoe UI" pitchFamily="34" charset="-122"/>
+                <a:cs typeface="Segoe UI" pitchFamily="34" charset="-120"/>
+              </a:rPr>
+              <a:t>Date defaults to today</a:t>
+            </a:r>
+            <a:endParaRPr lang="en-US" sz="1450" dirty="0"/>
+          </a:p>
+        </p:txBody>
+      </p:sp>
+      <p:sp>
+        <p:nvSpPr>
+          <p:cNvPr id="17" name="Text 15"/>
+          <p:cNvSpPr/>
+          <p:nvPr/>
+        </p:nvSpPr>
+        <p:spPr>
+          <a:xfrm>
+            <a:off x="896112" y="4773168"/>
+            <a:ext cx="4773168" cy="566928"/>
+          </a:xfrm>
+          <a:prstGeom prst="rect">
+            <a:avLst/>
+          </a:prstGeom>
+          <a:noFill/>
+          <a:ln/>
+        </p:spPr>
+        <p:txBody>
+          <a:bodyPr wrap="square" rtlCol="0" anchor="ctr"/>
+          <a:lstStyle/>
+          <a:p>
+            <a:pPr indent="0" marL="0">
+              <a:lnSpc>
+                <a:spcPct val="115000"/>
+              </a:lnSpc>
+              <a:buNone/>
+            </a:pPr>
+            <a:r>
+              <a:rPr lang="en-US" sz="1150" dirty="0">
+                <a:solidFill>
+                  <a:srgbClr val="475569"/>
+                </a:solidFill>
+                <a:latin typeface="Segoe UI" pitchFamily="34" charset="0"/>
+                <a:ea typeface="Segoe UI" pitchFamily="34" charset="-122"/>
+                <a:cs typeface="Segoe UI" pitchFamily="34" charset="-120"/>
+              </a:rPr>
+              <a:t>Can't be set in the future, keeping every report tied to a real site day.</a:t>
+            </a:r>
+            <a:endParaRPr lang="en-US" sz="1150" dirty="0"/>
+          </a:p>
+        </p:txBody>
+      </p:sp>
+      <p:pic>
+        <p:nvPicPr>
+          <p:cNvPr id="18" name="Image 0" descr="shots/06_dpr_form_filled_meta.png">    </p:cNvPr>
+          <p:cNvPicPr>
+            <a:picLocks noChangeAspect="1"/>
+          </p:cNvPicPr>
+          <p:nvPr/>
+        </p:nvPicPr>
+        <p:blipFill>
+          <a:blip r:embed="rId1"/>
+          <a:stretch>
+            <a:fillRect/>
+          </a:stretch>
+        </p:blipFill>
+        <p:spPr>
+          <a:xfrm>
+            <a:off x="5989320" y="1600200"/>
+            <a:ext cx="5669280" cy="4663440"/>
+          </a:xfrm>
+          <a:prstGeom prst="rect">
+            <a:avLst/>
+          </a:prstGeom>
+          <a:effectLst>
+            <a:outerShdw sx="100000" sy="100000" kx="0" ky="0" algn="bl" rotWithShape="0" blurRad="228600" dist="76200" dir="5400000">
+              <a:srgbClr val="1A1A2E">
+                <a:alpha val="35000"/>
+              </a:srgbClr>
+            </a:outerShdw>
+          </a:effectLst>
+        </p:spPr>
+      </p:pic>
+      <p:sp>
+        <p:nvSpPr>
+          <p:cNvPr id="19" name="Text 16"/>
+          <p:cNvSpPr/>
+          <p:nvPr/>
+        </p:nvSpPr>
+        <p:spPr>
+          <a:xfrm>
+            <a:off x="457200" y="6547104"/>
+            <a:ext cx="5486400" cy="274320"/>
+          </a:xfrm>
+          <a:prstGeom prst="rect">
+            <a:avLst/>
+          </a:prstGeom>
+          <a:noFill/>
+          <a:ln/>
+        </p:spPr>
+        <p:txBody>
+          <a:bodyPr wrap="square" rtlCol="0" anchor="ctr"/>
+          <a:lstStyle/>
+          <a:p>
+            <a:pPr indent="0" marL="0">
+              <a:buNone/>
+            </a:pPr>
+            <a:r>
+              <a:rPr lang="en-US" sz="900" dirty="0">
+                <a:solidFill>
+                  <a:srgbClr val="94A3B8"/>
+                </a:solidFill>
+                <a:latin typeface="Segoe UI" pitchFamily="34" charset="0"/>
+                <a:ea typeface="Segoe UI" pitchFamily="34" charset="-122"/>
+                <a:cs typeface="Segoe UI" pitchFamily="34" charset="-120"/>
+              </a:rPr>
+              <a:t>Nexora ERP  ·  DRI Dashboard Overview</a:t>
+            </a:r>
+            <a:endParaRPr lang="en-US" sz="900" dirty="0"/>
+          </a:p>
+        </p:txBody>
+      </p:sp>
+      <p:sp>
+        <p:nvSpPr>
+          <p:cNvPr id="20" name="Text 17"/>
+          <p:cNvSpPr/>
+          <p:nvPr/>
+        </p:nvSpPr>
+        <p:spPr>
+          <a:xfrm>
+            <a:off x="11521440" y="6547104"/>
+            <a:ext cx="365760" cy="274320"/>
+          </a:xfrm>
+          <a:prstGeom prst="rect">
+            <a:avLst/>
+          </a:prstGeom>
+          <a:noFill/>
+          <a:ln/>
+        </p:spPr>
+        <p:txBody>
+          <a:bodyPr wrap="square" rtlCol="0" anchor="ctr"/>
+          <a:lstStyle/>
+          <a:p>
+            <a:pPr algn="r" indent="0" marL="0">
+              <a:buNone/>
+            </a:pPr>
+            <a:r>
+              <a:rPr lang="en-US" sz="900" dirty="0">
+                <a:solidFill>
+                  <a:srgbClr val="94A3B8"/>
+                </a:solidFill>
+                <a:latin typeface="Segoe UI" pitchFamily="34" charset="0"/>
+                <a:ea typeface="Segoe UI" pitchFamily="34" charset="-122"/>
+                <a:cs typeface="Segoe UI" pitchFamily="34" charset="-120"/>
+              </a:rPr>
+              <a:t>4</a:t>
+            </a:r>
+            <a:endParaRPr lang="en-US" sz="900" dirty="0"/>
           </a:p>
         </p:txBody>
       </p:sp>
@@ -6601,7 +5840,7 @@
                 <a:ea typeface="Segoe UI" pitchFamily="34" charset="-122"/>
                 <a:cs typeface="Segoe UI" pitchFamily="34" charset="-120"/>
               </a:rPr>
-              <a:t>Daily Progress Report — Overview</a:t>
+              <a:t>Work-Type Checklist + Photo Evidence</a:t>
             </a:r>
             <a:endParaRPr lang="en-US" sz="2400" dirty="0"/>
           </a:p>
@@ -6642,7 +5881,7 @@
                 <a:ea typeface="Segoe UI" pitchFamily="34" charset="-122"/>
                 <a:cs typeface="Segoe UI" pitchFamily="34" charset="-120"/>
               </a:rPr>
-              <a:t>Replaces two separate paper-style reports with a single, photo-verified daily submission.</a:t>
+              <a:t>32 real construction categories — check what happened today, then prove it with photos.</a:t>
             </a:r>
             <a:endParaRPr lang="en-US" sz="1250" dirty="0"/>
           </a:p>
@@ -6701,7 +5940,7 @@
                 <a:ea typeface="Segoe UI" pitchFamily="34" charset="-122"/>
                 <a:cs typeface="Segoe UI" pitchFamily="34" charset="-120"/>
               </a:rPr>
-              <a:t>One submission per site day</a:t>
+              <a:t>Check every category that applied</a:t>
             </a:r>
             <a:endParaRPr lang="en-US" sz="1450" dirty="0"/>
           </a:p>
@@ -6743,7 +5982,7 @@
                 <a:ea typeface="Segoe UI" pitchFamily="34" charset="-122"/>
                 <a:cs typeface="Segoe UI" pitchFamily="34" charset="-120"/>
               </a:rPr>
-              <a:t>Project, DRI name, date, contractor, shift, and today's labour count — all in one place.</a:t>
+              <a:t>Civil, Electrical, Plumbing, Waterproofing, and 28 more — a DRI checks exactly what work happened.</a:t>
             </a:r>
             <a:endParaRPr lang="en-US" sz="1150" dirty="0"/>
           </a:p>
@@ -6802,7 +6041,7 @@
                 <a:ea typeface="Segoe UI" pitchFamily="34" charset="-122"/>
                 <a:cs typeface="Segoe UI" pitchFamily="34" charset="-120"/>
               </a:rPr>
-              <a:t>Every report is listed</a:t>
+              <a:t>5-photo minimum per category</a:t>
             </a:r>
             <a:endParaRPr lang="en-US" sz="1450" dirty="0"/>
           </a:p>
@@ -6844,7 +6083,7 @@
                 <a:ea typeface="Segoe UI" pitchFamily="34" charset="-122"/>
                 <a:cs typeface="Segoe UI" pitchFamily="34" charset="-120"/>
               </a:rPr>
-              <a:t>The Recent Reports table shows what's been logged, by whom, and how many categories were covered.</a:t>
+              <a:t>Checking a box opens its own photo slot — at least 5 site photos are required before it counts as covered.</a:t>
             </a:r>
             <a:endParaRPr lang="en-US" sz="1150" dirty="0"/>
           </a:p>
@@ -6903,7 +6142,7 @@
                 <a:ea typeface="Segoe UI" pitchFamily="34" charset="-122"/>
                 <a:cs typeface="Segoe UI" pitchFamily="34" charset="-120"/>
               </a:rPr>
-              <a:t>Raise a Drawing Request inline</a:t>
+              <a:t>Photos are compressed automatically</a:t>
             </a:r>
             <a:endParaRPr lang="en-US" sz="1450" dirty="0"/>
           </a:p>
@@ -6945,7 +6184,7 @@
                 <a:ea typeface="Segoe UI" pitchFamily="34" charset="-122"/>
                 <a:cs typeface="Segoe UI" pitchFamily="34" charset="-120"/>
               </a:rPr>
-              <a:t>A DRI who hits a missing drawing while filling this out can raise it without leaving the page.</a:t>
+              <a:t>Images are resized and compressed client-side so a full day's evidence stays lightweight to submit.</a:t>
             </a:r>
             <a:endParaRPr lang="en-US" sz="1150" dirty="0"/>
           </a:p>
@@ -7004,7 +6243,7 @@
                 <a:ea typeface="Segoe UI" pitchFamily="34" charset="-122"/>
                 <a:cs typeface="Segoe UI" pitchFamily="34" charset="-120"/>
               </a:rPr>
-              <a:t>Available two ways</a:t>
+              <a:t>Nothing submits until it's complete</a:t>
             </a:r>
             <a:endParaRPr lang="en-US" sz="1450" dirty="0"/>
           </a:p>
@@ -7046,7 +6285,7 @@
                 <a:ea typeface="Segoe UI" pitchFamily="34" charset="-122"/>
                 <a:cs typeface="Segoe UI" pitchFamily="34" charset="-120"/>
               </a:rPr>
-              <a:t>Inside the app for logged-in DRIs/Admins, and as a public no-login form for anyone on site.</a:t>
+              <a:t>The Submit button validates every checked category has its minimum photos before it goes through.</a:t>
             </a:r>
             <a:endParaRPr lang="en-US" sz="1150" dirty="0"/>
           </a:p>
@@ -7054,7 +6293,7 @@
       </p:sp>
       <p:pic>
         <p:nvPicPr>
-          <p:cNvPr id="18" name="Image 0" descr="shots/09_dpr_submitted_list.png">    </p:cNvPr>
+          <p:cNvPr id="18" name="Image 0" descr="shots/08_dpr_photos_uploaded.png">    </p:cNvPr>
           <p:cNvPicPr>
             <a:picLocks noChangeAspect="1"/>
           </p:cNvPicPr>
@@ -7155,7 +6394,7 @@
                 <a:ea typeface="Segoe UI" pitchFamily="34" charset="-122"/>
                 <a:cs typeface="Segoe UI" pitchFamily="34" charset="-120"/>
               </a:rPr>
-              <a:t>6</a:t>
+              <a:t>5</a:t>
             </a:r>
             <a:endParaRPr lang="en-US" sz="900" dirty="0"/>
           </a:p>
@@ -7266,7 +6505,7 @@
                 <a:ea typeface="Segoe UI" pitchFamily="34" charset="-122"/>
                 <a:cs typeface="Segoe UI" pitchFamily="34" charset="-120"/>
               </a:rPr>
-              <a:t>Filling In a Report</a:t>
+              <a:t>Reviewing a Submitted Report</a:t>
             </a:r>
             <a:endParaRPr lang="en-US" sz="2400" dirty="0"/>
           </a:p>
@@ -7307,7 +6546,7 @@
                 <a:ea typeface="Segoe UI" pitchFamily="34" charset="-122"/>
                 <a:cs typeface="Segoe UI" pitchFamily="34" charset="-120"/>
               </a:rPr>
-              <a:t>Report Details up top, the work-type checklist below — both in one wide, well-spaced drawer.</a:t>
+              <a:t>Every category's photo evidence stays attached to the report, viewable any time.</a:t>
             </a:r>
             <a:endParaRPr lang="en-US" sz="1250" dirty="0"/>
           </a:p>
@@ -7366,7 +6605,7 @@
                 <a:ea typeface="Segoe UI" pitchFamily="34" charset="-122"/>
                 <a:cs typeface="Segoe UI" pitchFamily="34" charset="-120"/>
               </a:rPr>
-              <a:t>Project &amp; Contractor</a:t>
+              <a:t>Full report summary</a:t>
             </a:r>
             <a:endParaRPr lang="en-US" sz="1450" dirty="0"/>
           </a:p>
@@ -7408,7 +6647,7 @@
                 <a:ea typeface="Segoe UI" pitchFamily="34" charset="-122"/>
                 <a:cs typeface="Segoe UI" pitchFamily="34" charset="-120"/>
               </a:rPr>
-              <a:t>Searchable dropdowns pull from the same live Projects and Contractors lists used across the app.</a:t>
+              <a:t>Date, DRI, contractor, shift, and labour count are all shown together at the top.</a:t>
             </a:r>
             <a:endParaRPr lang="en-US" sz="1150" dirty="0"/>
           </a:p>
@@ -7467,7 +6706,7 @@
                 <a:ea typeface="Segoe UI" pitchFamily="34" charset="-122"/>
                 <a:cs typeface="Segoe UI" pitchFamily="34" charset="-120"/>
               </a:rPr>
-              <a:t>DRI Name is a dropdown here</a:t>
+              <a:t>Photo evidence, per category</a:t>
             </a:r>
             <a:endParaRPr lang="en-US" sz="1450" dirty="0"/>
           </a:p>
@@ -7509,7 +6748,7 @@
                 <a:ea typeface="Segoe UI" pitchFamily="34" charset="-122"/>
                 <a:cs typeface="Segoe UI" pitchFamily="34" charset="-120"/>
               </a:rPr>
-              <a:t>Inside the app it's picked from registered site DRIs — the public form uses a free-text field instead.</a:t>
+              <a:t>Each checked work type keeps its own gallery of site photos — click through to open full size.</a:t>
             </a:r>
             <a:endParaRPr lang="en-US" sz="1150" dirty="0"/>
           </a:p>
@@ -7568,7 +6807,7 @@
                 <a:ea typeface="Segoe UI" pitchFamily="34" charset="-122"/>
                 <a:cs typeface="Segoe UI" pitchFamily="34" charset="-120"/>
               </a:rPr>
-              <a:t>Shift &amp; labour count</a:t>
+              <a:t>A permanent, auditable record</a:t>
             </a:r>
             <a:endParaRPr lang="en-US" sz="1450" dirty="0"/>
           </a:p>
@@ -7610,108 +6849,7 @@
                 <a:ea typeface="Segoe UI" pitchFamily="34" charset="-122"/>
                 <a:cs typeface="Segoe UI" pitchFamily="34" charset="-120"/>
               </a:rPr>
-              <a:t>Day or Night shift, plus how many labourers were on site — quick to fill, nothing optional missed.</a:t>
-            </a:r>
-            <a:endParaRPr lang="en-US" sz="1150" dirty="0"/>
-          </a:p>
-        </p:txBody>
-      </p:sp>
-      <p:sp>
-        <p:nvSpPr>
-          <p:cNvPr id="15" name="Shape 13"/>
-          <p:cNvSpPr/>
-          <p:nvPr/>
-        </p:nvSpPr>
-        <p:spPr>
-          <a:xfrm>
-            <a:off x="640080" y="4617720"/>
-            <a:ext cx="82296" cy="82296"/>
-          </a:xfrm>
-          <a:prstGeom prst="rect">
-            <a:avLst/>
-          </a:prstGeom>
-          <a:solidFill>
-            <a:srgbClr val="4F46E5"/>
-          </a:solidFill>
-          <a:ln/>
-        </p:spPr>
-      </p:sp>
-      <p:sp>
-        <p:nvSpPr>
-          <p:cNvPr id="16" name="Text 14"/>
-          <p:cNvSpPr/>
-          <p:nvPr/>
-        </p:nvSpPr>
-        <p:spPr>
-          <a:xfrm>
-            <a:off x="896112" y="4480560"/>
-            <a:ext cx="4773168" cy="292608"/>
-          </a:xfrm>
-          <a:prstGeom prst="rect">
-            <a:avLst/>
-          </a:prstGeom>
-          <a:noFill/>
-          <a:ln/>
-        </p:spPr>
-        <p:txBody>
-          <a:bodyPr wrap="square" rtlCol="0" anchor="ctr"/>
-          <a:lstStyle/>
-          <a:p>
-            <a:pPr indent="0" marL="0">
-              <a:buNone/>
-            </a:pPr>
-            <a:r>
-              <a:rPr lang="en-US" sz="1450" b="1" dirty="0">
-                <a:solidFill>
-                  <a:srgbClr val="1A1A2E"/>
-                </a:solidFill>
-                <a:latin typeface="Segoe UI" pitchFamily="34" charset="0"/>
-                <a:ea typeface="Segoe UI" pitchFamily="34" charset="-122"/>
-                <a:cs typeface="Segoe UI" pitchFamily="34" charset="-120"/>
-              </a:rPr>
-              <a:t>Date defaults to today</a:t>
-            </a:r>
-            <a:endParaRPr lang="en-US" sz="1450" dirty="0"/>
-          </a:p>
-        </p:txBody>
-      </p:sp>
-      <p:sp>
-        <p:nvSpPr>
-          <p:cNvPr id="17" name="Text 15"/>
-          <p:cNvSpPr/>
-          <p:nvPr/>
-        </p:nvSpPr>
-        <p:spPr>
-          <a:xfrm>
-            <a:off x="896112" y="4773168"/>
-            <a:ext cx="4773168" cy="566928"/>
-          </a:xfrm>
-          <a:prstGeom prst="rect">
-            <a:avLst/>
-          </a:prstGeom>
-          <a:noFill/>
-          <a:ln/>
-        </p:spPr>
-        <p:txBody>
-          <a:bodyPr wrap="square" rtlCol="0" anchor="ctr"/>
-          <a:lstStyle/>
-          <a:p>
-            <a:pPr indent="0" marL="0">
-              <a:lnSpc>
-                <a:spcPct val="115000"/>
-              </a:lnSpc>
-              <a:buNone/>
-            </a:pPr>
-            <a:r>
-              <a:rPr lang="en-US" sz="1150" dirty="0">
-                <a:solidFill>
-                  <a:srgbClr val="475569"/>
-                </a:solidFill>
-                <a:latin typeface="Segoe UI" pitchFamily="34" charset="0"/>
-                <a:ea typeface="Segoe UI" pitchFamily="34" charset="-122"/>
-                <a:cs typeface="Segoe UI" pitchFamily="34" charset="-120"/>
-              </a:rPr>
-              <a:t>Can't be set in the future, keeping every report tied to a real site day.</a:t>
+              <a:t>Once submitted, the report and its photos become part of that project's history.</a:t>
             </a:r>
             <a:endParaRPr lang="en-US" sz="1150" dirty="0"/>
           </a:p>
@@ -7719,7 +6857,7 @@
       </p:sp>
       <p:pic>
         <p:nvPicPr>
-          <p:cNvPr id="18" name="Image 0" descr="shots/06_dpr_form_filled_meta.png">    </p:cNvPr>
+          <p:cNvPr id="15" name="Image 0" descr="shots/10_dpr_view_detail.png">    </p:cNvPr>
           <p:cNvPicPr>
             <a:picLocks noChangeAspect="1"/>
           </p:cNvPicPr>
@@ -7750,7 +6888,7 @@
       </p:pic>
       <p:sp>
         <p:nvSpPr>
-          <p:cNvPr id="19" name="Text 16"/>
+          <p:cNvPr id="16" name="Text 13"/>
           <p:cNvSpPr/>
           <p:nvPr/>
         </p:nvSpPr>
@@ -7789,7 +6927,7 @@
       </p:sp>
       <p:sp>
         <p:nvSpPr>
-          <p:cNvPr id="20" name="Text 17"/>
+          <p:cNvPr id="17" name="Text 14"/>
           <p:cNvSpPr/>
           <p:nvPr/>
         </p:nvSpPr>
@@ -7820,7 +6958,7 @@
                 <a:ea typeface="Segoe UI" pitchFamily="34" charset="-122"/>
                 <a:cs typeface="Segoe UI" pitchFamily="34" charset="-120"/>
               </a:rPr>
-              <a:t>7</a:t>
+              <a:t>6</a:t>
             </a:r>
             <a:endParaRPr lang="en-US" sz="900" dirty="0"/>
           </a:p>
@@ -7840,7 +6978,7 @@
     <p:bg>
       <p:bgPr>
         <a:solidFill>
-          <a:srgbClr val="FFFFFF"/>
+          <a:srgbClr val="7C3AED"/>
         </a:solidFill>
       </p:bgPr>
     </p:bg>
@@ -7860,23 +6998,44 @@
       </p:grpSpPr>
       <p:sp>
         <p:nvSpPr>
-          <p:cNvPr id="2" name="Shape 0"/>
-          <p:cNvSpPr/>
-          <p:nvPr/>
-        </p:nvSpPr>
-        <p:spPr>
-          <a:xfrm>
-            <a:off x="0" y="0"/>
-            <a:ext cx="12191695" cy="1234440"/>
-          </a:xfrm>
-          <a:prstGeom prst="rect">
-            <a:avLst/>
-          </a:prstGeom>
-          <a:solidFill>
-            <a:srgbClr val="4F46E5"/>
-          </a:solidFill>
-          <a:ln/>
-        </p:spPr>
+          <p:cNvPr id="2" name="Text 0"/>
+          <p:cNvSpPr/>
+          <p:nvPr/>
+        </p:nvSpPr>
+        <p:spPr>
+          <a:xfrm>
+            <a:off x="822960" y="2011680"/>
+            <a:ext cx="2743200" cy="1463040"/>
+          </a:xfrm>
+          <a:prstGeom prst="rect">
+            <a:avLst/>
+          </a:prstGeom>
+          <a:noFill/>
+          <a:ln/>
+        </p:spPr>
+        <p:txBody>
+          <a:bodyPr wrap="square" rtlCol="0" anchor="ctr"/>
+          <a:lstStyle/>
+          <a:p>
+            <a:pPr indent="0" marL="0">
+              <a:buNone/>
+            </a:pPr>
+            <a:r>
+              <a:rPr lang="en-US" sz="9000" b="1" dirty="0">
+                <a:solidFill>
+                  <a:srgbClr val="FFFFFF">
+                    <a:alpha val="30000"/>
+                  </a:srgbClr>
+                </a:solidFill>
+                <a:latin typeface="Segoe UI" pitchFamily="34" charset="0"/>
+                <a:ea typeface="Segoe UI" pitchFamily="34" charset="-122"/>
+                <a:cs typeface="Segoe UI" pitchFamily="34" charset="-120"/>
+              </a:rPr>
+              <a:t>02</a:t>
+            </a:r>
+            <a:endParaRPr lang="en-US" sz="9000" dirty="0"/>
+          </a:p>
+        </p:txBody>
       </p:sp>
       <p:sp>
         <p:nvSpPr>
@@ -7886,8 +7045,8 @@
         </p:nvSpPr>
         <p:spPr>
           <a:xfrm>
-            <a:off x="502920" y="310896"/>
-            <a:ext cx="82296" cy="621792"/>
+            <a:off x="868680" y="3429000"/>
+            <a:ext cx="1280160" cy="64008"/>
           </a:xfrm>
           <a:prstGeom prst="rect">
             <a:avLst/>
@@ -7906,24 +7065,24 @@
         </p:nvSpPr>
         <p:spPr>
           <a:xfrm>
-            <a:off x="777240" y="237744"/>
-            <a:ext cx="9601200" cy="502920"/>
-          </a:xfrm>
-          <a:prstGeom prst="rect">
-            <a:avLst/>
-          </a:prstGeom>
-          <a:noFill/>
-          <a:ln/>
-        </p:spPr>
-        <p:txBody>
-          <a:bodyPr wrap="square" rtlCol="0" anchor="ctr"/>
-          <a:lstStyle/>
-          <a:p>
-            <a:pPr indent="0" marL="0">
-              <a:buNone/>
-            </a:pPr>
-            <a:r>
-              <a:rPr lang="en-US" sz="2400" b="1" dirty="0">
+            <a:off x="822960" y="3611880"/>
+            <a:ext cx="10058400" cy="914400"/>
+          </a:xfrm>
+          <a:prstGeom prst="rect">
+            <a:avLst/>
+          </a:prstGeom>
+          <a:noFill/>
+          <a:ln/>
+        </p:spPr>
+        <p:txBody>
+          <a:bodyPr wrap="square" rtlCol="0" anchor="ctr"/>
+          <a:lstStyle/>
+          <a:p>
+            <a:pPr indent="0" marL="0">
+              <a:buNone/>
+            </a:pPr>
+            <a:r>
+              <a:rPr lang="en-US" sz="4000" b="1" dirty="0">
                 <a:solidFill>
                   <a:srgbClr val="FFFFFF"/>
                 </a:solidFill>
@@ -7931,9 +7090,9 @@
                 <a:ea typeface="Segoe UI" pitchFamily="34" charset="-122"/>
                 <a:cs typeface="Segoe UI" pitchFamily="34" charset="-120"/>
               </a:rPr>
-              <a:t>Work-Type Checklist + Photo Evidence</a:t>
-            </a:r>
-            <a:endParaRPr lang="en-US" sz="2400" dirty="0"/>
+              <a:t>Drawing Requests</a:t>
+            </a:r>
+            <a:endParaRPr lang="en-US" sz="4000" dirty="0"/>
           </a:p>
         </p:txBody>
       </p:sp>
@@ -7945,24 +7104,24 @@
         </p:nvSpPr>
         <p:spPr>
           <a:xfrm>
-            <a:off x="777240" y="713232"/>
-            <a:ext cx="10515600" cy="365760"/>
-          </a:xfrm>
-          <a:prstGeom prst="rect">
-            <a:avLst/>
-          </a:prstGeom>
-          <a:noFill/>
-          <a:ln/>
-        </p:spPr>
-        <p:txBody>
-          <a:bodyPr wrap="square" rtlCol="0" anchor="ctr"/>
-          <a:lstStyle/>
-          <a:p>
-            <a:pPr indent="0" marL="0">
-              <a:buNone/>
-            </a:pPr>
-            <a:r>
-              <a:rPr lang="en-US" sz="1250" dirty="0">
+            <a:off x="822960" y="4434840"/>
+            <a:ext cx="9144000" cy="548640"/>
+          </a:xfrm>
+          <a:prstGeom prst="rect">
+            <a:avLst/>
+          </a:prstGeom>
+          <a:noFill/>
+          <a:ln/>
+        </p:spPr>
+        <p:txBody>
+          <a:bodyPr wrap="square" rtlCol="0" anchor="ctr"/>
+          <a:lstStyle/>
+          <a:p>
+            <a:pPr indent="0" marL="0">
+              <a:buNone/>
+            </a:pPr>
+            <a:r>
+              <a:rPr lang="en-US" sz="1500" dirty="0">
                 <a:solidFill>
                   <a:srgbClr val="FFFFFF">
                     <a:alpha val="85000"/>
@@ -7972,522 +7131,9 @@
                 <a:ea typeface="Segoe UI" pitchFamily="34" charset="-122"/>
                 <a:cs typeface="Segoe UI" pitchFamily="34" charset="-120"/>
               </a:rPr>
-              <a:t>32 real construction categories — check what happened today, then prove it with photos.</a:t>
-            </a:r>
-            <a:endParaRPr lang="en-US" sz="1250" dirty="0"/>
-          </a:p>
-        </p:txBody>
-      </p:sp>
-      <p:sp>
-        <p:nvSpPr>
-          <p:cNvPr id="6" name="Shape 4"/>
-          <p:cNvSpPr/>
-          <p:nvPr/>
-        </p:nvSpPr>
-        <p:spPr>
-          <a:xfrm>
-            <a:off x="640080" y="1819656"/>
-            <a:ext cx="82296" cy="82296"/>
-          </a:xfrm>
-          <a:prstGeom prst="rect">
-            <a:avLst/>
-          </a:prstGeom>
-          <a:solidFill>
-            <a:srgbClr val="4F46E5"/>
-          </a:solidFill>
-          <a:ln/>
-        </p:spPr>
-      </p:sp>
-      <p:sp>
-        <p:nvSpPr>
-          <p:cNvPr id="7" name="Text 5"/>
-          <p:cNvSpPr/>
-          <p:nvPr/>
-        </p:nvSpPr>
-        <p:spPr>
-          <a:xfrm>
-            <a:off x="896112" y="1682496"/>
-            <a:ext cx="4773168" cy="292608"/>
-          </a:xfrm>
-          <a:prstGeom prst="rect">
-            <a:avLst/>
-          </a:prstGeom>
-          <a:noFill/>
-          <a:ln/>
-        </p:spPr>
-        <p:txBody>
-          <a:bodyPr wrap="square" rtlCol="0" anchor="ctr"/>
-          <a:lstStyle/>
-          <a:p>
-            <a:pPr indent="0" marL="0">
-              <a:buNone/>
-            </a:pPr>
-            <a:r>
-              <a:rPr lang="en-US" sz="1450" b="1" dirty="0">
-                <a:solidFill>
-                  <a:srgbClr val="1A1A2E"/>
-                </a:solidFill>
-                <a:latin typeface="Segoe UI" pitchFamily="34" charset="0"/>
-                <a:ea typeface="Segoe UI" pitchFamily="34" charset="-122"/>
-                <a:cs typeface="Segoe UI" pitchFamily="34" charset="-120"/>
-              </a:rPr>
-              <a:t>Check every category that applied</a:t>
-            </a:r>
-            <a:endParaRPr lang="en-US" sz="1450" dirty="0"/>
-          </a:p>
-        </p:txBody>
-      </p:sp>
-      <p:sp>
-        <p:nvSpPr>
-          <p:cNvPr id="8" name="Text 6"/>
-          <p:cNvSpPr/>
-          <p:nvPr/>
-        </p:nvSpPr>
-        <p:spPr>
-          <a:xfrm>
-            <a:off x="896112" y="1975104"/>
-            <a:ext cx="4773168" cy="566928"/>
-          </a:xfrm>
-          <a:prstGeom prst="rect">
-            <a:avLst/>
-          </a:prstGeom>
-          <a:noFill/>
-          <a:ln/>
-        </p:spPr>
-        <p:txBody>
-          <a:bodyPr wrap="square" rtlCol="0" anchor="ctr"/>
-          <a:lstStyle/>
-          <a:p>
-            <a:pPr indent="0" marL="0">
-              <a:lnSpc>
-                <a:spcPct val="115000"/>
-              </a:lnSpc>
-              <a:buNone/>
-            </a:pPr>
-            <a:r>
-              <a:rPr lang="en-US" sz="1150" dirty="0">
-                <a:solidFill>
-                  <a:srgbClr val="475569"/>
-                </a:solidFill>
-                <a:latin typeface="Segoe UI" pitchFamily="34" charset="0"/>
-                <a:ea typeface="Segoe UI" pitchFamily="34" charset="-122"/>
-                <a:cs typeface="Segoe UI" pitchFamily="34" charset="-120"/>
-              </a:rPr>
-              <a:t>Civil, Electrical, Plumbing, Waterproofing, and 28 more — a DRI checks exactly what work happened.</a:t>
-            </a:r>
-            <a:endParaRPr lang="en-US" sz="1150" dirty="0"/>
-          </a:p>
-        </p:txBody>
-      </p:sp>
-      <p:sp>
-        <p:nvSpPr>
-          <p:cNvPr id="9" name="Shape 7"/>
-          <p:cNvSpPr/>
-          <p:nvPr/>
-        </p:nvSpPr>
-        <p:spPr>
-          <a:xfrm>
-            <a:off x="640080" y="2752344"/>
-            <a:ext cx="82296" cy="82296"/>
-          </a:xfrm>
-          <a:prstGeom prst="rect">
-            <a:avLst/>
-          </a:prstGeom>
-          <a:solidFill>
-            <a:srgbClr val="4F46E5"/>
-          </a:solidFill>
-          <a:ln/>
-        </p:spPr>
-      </p:sp>
-      <p:sp>
-        <p:nvSpPr>
-          <p:cNvPr id="10" name="Text 8"/>
-          <p:cNvSpPr/>
-          <p:nvPr/>
-        </p:nvSpPr>
-        <p:spPr>
-          <a:xfrm>
-            <a:off x="896112" y="2615184"/>
-            <a:ext cx="4773168" cy="292608"/>
-          </a:xfrm>
-          <a:prstGeom prst="rect">
-            <a:avLst/>
-          </a:prstGeom>
-          <a:noFill/>
-          <a:ln/>
-        </p:spPr>
-        <p:txBody>
-          <a:bodyPr wrap="square" rtlCol="0" anchor="ctr"/>
-          <a:lstStyle/>
-          <a:p>
-            <a:pPr indent="0" marL="0">
-              <a:buNone/>
-            </a:pPr>
-            <a:r>
-              <a:rPr lang="en-US" sz="1450" b="1" dirty="0">
-                <a:solidFill>
-                  <a:srgbClr val="1A1A2E"/>
-                </a:solidFill>
-                <a:latin typeface="Segoe UI" pitchFamily="34" charset="0"/>
-                <a:ea typeface="Segoe UI" pitchFamily="34" charset="-122"/>
-                <a:cs typeface="Segoe UI" pitchFamily="34" charset="-120"/>
-              </a:rPr>
-              <a:t>5-photo minimum per category</a:t>
-            </a:r>
-            <a:endParaRPr lang="en-US" sz="1450" dirty="0"/>
-          </a:p>
-        </p:txBody>
-      </p:sp>
-      <p:sp>
-        <p:nvSpPr>
-          <p:cNvPr id="11" name="Text 9"/>
-          <p:cNvSpPr/>
-          <p:nvPr/>
-        </p:nvSpPr>
-        <p:spPr>
-          <a:xfrm>
-            <a:off x="896112" y="2907792"/>
-            <a:ext cx="4773168" cy="566928"/>
-          </a:xfrm>
-          <a:prstGeom prst="rect">
-            <a:avLst/>
-          </a:prstGeom>
-          <a:noFill/>
-          <a:ln/>
-        </p:spPr>
-        <p:txBody>
-          <a:bodyPr wrap="square" rtlCol="0" anchor="ctr"/>
-          <a:lstStyle/>
-          <a:p>
-            <a:pPr indent="0" marL="0">
-              <a:lnSpc>
-                <a:spcPct val="115000"/>
-              </a:lnSpc>
-              <a:buNone/>
-            </a:pPr>
-            <a:r>
-              <a:rPr lang="en-US" sz="1150" dirty="0">
-                <a:solidFill>
-                  <a:srgbClr val="475569"/>
-                </a:solidFill>
-                <a:latin typeface="Segoe UI" pitchFamily="34" charset="0"/>
-                <a:ea typeface="Segoe UI" pitchFamily="34" charset="-122"/>
-                <a:cs typeface="Segoe UI" pitchFamily="34" charset="-120"/>
-              </a:rPr>
-              <a:t>Checking a box opens its own photo slot — at least 5 site photos are required before it counts as covered.</a:t>
-            </a:r>
-            <a:endParaRPr lang="en-US" sz="1150" dirty="0"/>
-          </a:p>
-        </p:txBody>
-      </p:sp>
-      <p:sp>
-        <p:nvSpPr>
-          <p:cNvPr id="12" name="Shape 10"/>
-          <p:cNvSpPr/>
-          <p:nvPr/>
-        </p:nvSpPr>
-        <p:spPr>
-          <a:xfrm>
-            <a:off x="640080" y="3685032"/>
-            <a:ext cx="82296" cy="82296"/>
-          </a:xfrm>
-          <a:prstGeom prst="rect">
-            <a:avLst/>
-          </a:prstGeom>
-          <a:solidFill>
-            <a:srgbClr val="4F46E5"/>
-          </a:solidFill>
-          <a:ln/>
-        </p:spPr>
-      </p:sp>
-      <p:sp>
-        <p:nvSpPr>
-          <p:cNvPr id="13" name="Text 11"/>
-          <p:cNvSpPr/>
-          <p:nvPr/>
-        </p:nvSpPr>
-        <p:spPr>
-          <a:xfrm>
-            <a:off x="896112" y="3547872"/>
-            <a:ext cx="4773168" cy="292608"/>
-          </a:xfrm>
-          <a:prstGeom prst="rect">
-            <a:avLst/>
-          </a:prstGeom>
-          <a:noFill/>
-          <a:ln/>
-        </p:spPr>
-        <p:txBody>
-          <a:bodyPr wrap="square" rtlCol="0" anchor="ctr"/>
-          <a:lstStyle/>
-          <a:p>
-            <a:pPr indent="0" marL="0">
-              <a:buNone/>
-            </a:pPr>
-            <a:r>
-              <a:rPr lang="en-US" sz="1450" b="1" dirty="0">
-                <a:solidFill>
-                  <a:srgbClr val="1A1A2E"/>
-                </a:solidFill>
-                <a:latin typeface="Segoe UI" pitchFamily="34" charset="0"/>
-                <a:ea typeface="Segoe UI" pitchFamily="34" charset="-122"/>
-                <a:cs typeface="Segoe UI" pitchFamily="34" charset="-120"/>
-              </a:rPr>
-              <a:t>Photos are compressed automatically</a:t>
-            </a:r>
-            <a:endParaRPr lang="en-US" sz="1450" dirty="0"/>
-          </a:p>
-        </p:txBody>
-      </p:sp>
-      <p:sp>
-        <p:nvSpPr>
-          <p:cNvPr id="14" name="Text 12"/>
-          <p:cNvSpPr/>
-          <p:nvPr/>
-        </p:nvSpPr>
-        <p:spPr>
-          <a:xfrm>
-            <a:off x="896112" y="3840480"/>
-            <a:ext cx="4773168" cy="566928"/>
-          </a:xfrm>
-          <a:prstGeom prst="rect">
-            <a:avLst/>
-          </a:prstGeom>
-          <a:noFill/>
-          <a:ln/>
-        </p:spPr>
-        <p:txBody>
-          <a:bodyPr wrap="square" rtlCol="0" anchor="ctr"/>
-          <a:lstStyle/>
-          <a:p>
-            <a:pPr indent="0" marL="0">
-              <a:lnSpc>
-                <a:spcPct val="115000"/>
-              </a:lnSpc>
-              <a:buNone/>
-            </a:pPr>
-            <a:r>
-              <a:rPr lang="en-US" sz="1150" dirty="0">
-                <a:solidFill>
-                  <a:srgbClr val="475569"/>
-                </a:solidFill>
-                <a:latin typeface="Segoe UI" pitchFamily="34" charset="0"/>
-                <a:ea typeface="Segoe UI" pitchFamily="34" charset="-122"/>
-                <a:cs typeface="Segoe UI" pitchFamily="34" charset="-120"/>
-              </a:rPr>
-              <a:t>Images are resized and compressed client-side so a full day's evidence stays lightweight to submit.</a:t>
-            </a:r>
-            <a:endParaRPr lang="en-US" sz="1150" dirty="0"/>
-          </a:p>
-        </p:txBody>
-      </p:sp>
-      <p:sp>
-        <p:nvSpPr>
-          <p:cNvPr id="15" name="Shape 13"/>
-          <p:cNvSpPr/>
-          <p:nvPr/>
-        </p:nvSpPr>
-        <p:spPr>
-          <a:xfrm>
-            <a:off x="640080" y="4617720"/>
-            <a:ext cx="82296" cy="82296"/>
-          </a:xfrm>
-          <a:prstGeom prst="rect">
-            <a:avLst/>
-          </a:prstGeom>
-          <a:solidFill>
-            <a:srgbClr val="4F46E5"/>
-          </a:solidFill>
-          <a:ln/>
-        </p:spPr>
-      </p:sp>
-      <p:sp>
-        <p:nvSpPr>
-          <p:cNvPr id="16" name="Text 14"/>
-          <p:cNvSpPr/>
-          <p:nvPr/>
-        </p:nvSpPr>
-        <p:spPr>
-          <a:xfrm>
-            <a:off x="896112" y="4480560"/>
-            <a:ext cx="4773168" cy="292608"/>
-          </a:xfrm>
-          <a:prstGeom prst="rect">
-            <a:avLst/>
-          </a:prstGeom>
-          <a:noFill/>
-          <a:ln/>
-        </p:spPr>
-        <p:txBody>
-          <a:bodyPr wrap="square" rtlCol="0" anchor="ctr"/>
-          <a:lstStyle/>
-          <a:p>
-            <a:pPr indent="0" marL="0">
-              <a:buNone/>
-            </a:pPr>
-            <a:r>
-              <a:rPr lang="en-US" sz="1450" b="1" dirty="0">
-                <a:solidFill>
-                  <a:srgbClr val="1A1A2E"/>
-                </a:solidFill>
-                <a:latin typeface="Segoe UI" pitchFamily="34" charset="0"/>
-                <a:ea typeface="Segoe UI" pitchFamily="34" charset="-122"/>
-                <a:cs typeface="Segoe UI" pitchFamily="34" charset="-120"/>
-              </a:rPr>
-              <a:t>Nothing submits until it's complete</a:t>
-            </a:r>
-            <a:endParaRPr lang="en-US" sz="1450" dirty="0"/>
-          </a:p>
-        </p:txBody>
-      </p:sp>
-      <p:sp>
-        <p:nvSpPr>
-          <p:cNvPr id="17" name="Text 15"/>
-          <p:cNvSpPr/>
-          <p:nvPr/>
-        </p:nvSpPr>
-        <p:spPr>
-          <a:xfrm>
-            <a:off x="896112" y="4773168"/>
-            <a:ext cx="4773168" cy="566928"/>
-          </a:xfrm>
-          <a:prstGeom prst="rect">
-            <a:avLst/>
-          </a:prstGeom>
-          <a:noFill/>
-          <a:ln/>
-        </p:spPr>
-        <p:txBody>
-          <a:bodyPr wrap="square" rtlCol="0" anchor="ctr"/>
-          <a:lstStyle/>
-          <a:p>
-            <a:pPr indent="0" marL="0">
-              <a:lnSpc>
-                <a:spcPct val="115000"/>
-              </a:lnSpc>
-              <a:buNone/>
-            </a:pPr>
-            <a:r>
-              <a:rPr lang="en-US" sz="1150" dirty="0">
-                <a:solidFill>
-                  <a:srgbClr val="475569"/>
-                </a:solidFill>
-                <a:latin typeface="Segoe UI" pitchFamily="34" charset="0"/>
-                <a:ea typeface="Segoe UI" pitchFamily="34" charset="-122"/>
-                <a:cs typeface="Segoe UI" pitchFamily="34" charset="-120"/>
-              </a:rPr>
-              <a:t>The Submit button validates every checked category has its minimum photos before it goes through.</a:t>
-            </a:r>
-            <a:endParaRPr lang="en-US" sz="1150" dirty="0"/>
-          </a:p>
-        </p:txBody>
-      </p:sp>
-      <p:pic>
-        <p:nvPicPr>
-          <p:cNvPr id="18" name="Image 0" descr="shots/08_dpr_photos_uploaded.png">    </p:cNvPr>
-          <p:cNvPicPr>
-            <a:picLocks noChangeAspect="1"/>
-          </p:cNvPicPr>
-          <p:nvPr/>
-        </p:nvPicPr>
-        <p:blipFill>
-          <a:blip r:embed="rId1"/>
-          <a:stretch>
-            <a:fillRect/>
-          </a:stretch>
-        </p:blipFill>
-        <p:spPr>
-          <a:xfrm>
-            <a:off x="5989320" y="1600200"/>
-            <a:ext cx="5669280" cy="4663440"/>
-          </a:xfrm>
-          <a:prstGeom prst="rect">
-            <a:avLst/>
-          </a:prstGeom>
-          <a:effectLst>
-            <a:outerShdw sx="100000" sy="100000" kx="0" ky="0" algn="bl" rotWithShape="0" blurRad="228600" dist="76200" dir="5400000">
-              <a:srgbClr val="1A1A2E">
-                <a:alpha val="35000"/>
-              </a:srgbClr>
-            </a:outerShdw>
-          </a:effectLst>
-        </p:spPr>
-      </p:pic>
-      <p:sp>
-        <p:nvSpPr>
-          <p:cNvPr id="19" name="Text 16"/>
-          <p:cNvSpPr/>
-          <p:nvPr/>
-        </p:nvSpPr>
-        <p:spPr>
-          <a:xfrm>
-            <a:off x="457200" y="6547104"/>
-            <a:ext cx="5486400" cy="274320"/>
-          </a:xfrm>
-          <a:prstGeom prst="rect">
-            <a:avLst/>
-          </a:prstGeom>
-          <a:noFill/>
-          <a:ln/>
-        </p:spPr>
-        <p:txBody>
-          <a:bodyPr wrap="square" rtlCol="0" anchor="ctr"/>
-          <a:lstStyle/>
-          <a:p>
-            <a:pPr indent="0" marL="0">
-              <a:buNone/>
-            </a:pPr>
-            <a:r>
-              <a:rPr lang="en-US" sz="900" dirty="0">
-                <a:solidFill>
-                  <a:srgbClr val="94A3B8"/>
-                </a:solidFill>
-                <a:latin typeface="Segoe UI" pitchFamily="34" charset="0"/>
-                <a:ea typeface="Segoe UI" pitchFamily="34" charset="-122"/>
-                <a:cs typeface="Segoe UI" pitchFamily="34" charset="-120"/>
-              </a:rPr>
-              <a:t>Nexora ERP  ·  DRI Dashboard Overview</a:t>
-            </a:r>
-            <a:endParaRPr lang="en-US" sz="900" dirty="0"/>
-          </a:p>
-        </p:txBody>
-      </p:sp>
-      <p:sp>
-        <p:nvSpPr>
-          <p:cNvPr id="20" name="Text 17"/>
-          <p:cNvSpPr/>
-          <p:nvPr/>
-        </p:nvSpPr>
-        <p:spPr>
-          <a:xfrm>
-            <a:off x="11521440" y="6547104"/>
-            <a:ext cx="365760" cy="274320"/>
-          </a:xfrm>
-          <a:prstGeom prst="rect">
-            <a:avLst/>
-          </a:prstGeom>
-          <a:noFill/>
-          <a:ln/>
-        </p:spPr>
-        <p:txBody>
-          <a:bodyPr wrap="square" rtlCol="0" anchor="ctr"/>
-          <a:lstStyle/>
-          <a:p>
-            <a:pPr algn="r" indent="0" marL="0">
-              <a:buNone/>
-            </a:pPr>
-            <a:r>
-              <a:rPr lang="en-US" sz="900" dirty="0">
-                <a:solidFill>
-                  <a:srgbClr val="94A3B8"/>
-                </a:solidFill>
-                <a:latin typeface="Segoe UI" pitchFamily="34" charset="0"/>
-                <a:ea typeface="Segoe UI" pitchFamily="34" charset="-122"/>
-                <a:cs typeface="Segoe UI" pitchFamily="34" charset="-120"/>
-              </a:rPr>
-              <a:t>8</a:t>
-            </a:r>
-            <a:endParaRPr lang="en-US" sz="900" dirty="0"/>
+              <a:t>Raise it in seconds on site — track it through AGM, GM, and Planning until it's resolved.</a:t>
+            </a:r>
+            <a:endParaRPr lang="en-US" sz="1500" dirty="0"/>
           </a:p>
         </p:txBody>
       </p:sp>
@@ -8538,7 +7184,7 @@
             <a:avLst/>
           </a:prstGeom>
           <a:solidFill>
-            <a:srgbClr val="4F46E5"/>
+            <a:srgbClr val="7C3AED"/>
           </a:solidFill>
           <a:ln/>
         </p:spPr>
@@ -8596,7 +7242,7 @@
                 <a:ea typeface="Segoe UI" pitchFamily="34" charset="-122"/>
                 <a:cs typeface="Segoe UI" pitchFamily="34" charset="-120"/>
               </a:rPr>
-              <a:t>Reviewing a Submitted Report</a:t>
+              <a:t>Raising a Request</a:t>
             </a:r>
             <a:endParaRPr lang="en-US" sz="2400" dirty="0"/>
           </a:p>
@@ -8637,7 +7283,7 @@
                 <a:ea typeface="Segoe UI" pitchFamily="34" charset="-122"/>
                 <a:cs typeface="Segoe UI" pitchFamily="34" charset="-120"/>
               </a:rPr>
-              <a:t>Every category's photo evidence stays attached to the report, viewable any time.</a:t>
+              <a:t>A DRI stuck without a drawing raises a ticket without ever leaving the Daily Progress Report page.</a:t>
             </a:r>
             <a:endParaRPr lang="en-US" sz="1250" dirty="0"/>
           </a:p>
@@ -8658,7 +7304,7 @@
             <a:avLst/>
           </a:prstGeom>
           <a:solidFill>
-            <a:srgbClr val="4F46E5"/>
+            <a:srgbClr val="7C3AED"/>
           </a:solidFill>
           <a:ln/>
         </p:spPr>
@@ -8696,7 +7342,7 @@
                 <a:ea typeface="Segoe UI" pitchFamily="34" charset="-122"/>
                 <a:cs typeface="Segoe UI" pitchFamily="34" charset="-120"/>
               </a:rPr>
-              <a:t>Full report summary</a:t>
+              <a:t>One button, right where it's needed</a:t>
             </a:r>
             <a:endParaRPr lang="en-US" sz="1450" dirty="0"/>
           </a:p>
@@ -8738,7 +7384,7 @@
                 <a:ea typeface="Segoe UI" pitchFamily="34" charset="-122"/>
                 <a:cs typeface="Segoe UI" pitchFamily="34" charset="-120"/>
               </a:rPr>
-              <a:t>Date, DRI, contractor, shift, and labour count are all shown together at the top.</a:t>
+              <a:t>"Drawing Request" sits next to "New Report" on the Daily Progress Report page.</a:t>
             </a:r>
             <a:endParaRPr lang="en-US" sz="1150" dirty="0"/>
           </a:p>
@@ -8759,7 +7405,7 @@
             <a:avLst/>
           </a:prstGeom>
           <a:solidFill>
-            <a:srgbClr val="4F46E5"/>
+            <a:srgbClr val="7C3AED"/>
           </a:solidFill>
           <a:ln/>
         </p:spPr>
@@ -8797,7 +7443,7 @@
                 <a:ea typeface="Segoe UI" pitchFamily="34" charset="-122"/>
                 <a:cs typeface="Segoe UI" pitchFamily="34" charset="-120"/>
               </a:rPr>
-              <a:t>Photo evidence, per category</a:t>
+              <a:t>Just the essentials</a:t>
             </a:r>
             <a:endParaRPr lang="en-US" sz="1450" dirty="0"/>
           </a:p>
@@ -8839,7 +7485,7 @@
                 <a:ea typeface="Segoe UI" pitchFamily="34" charset="-122"/>
                 <a:cs typeface="Segoe UI" pitchFamily="34" charset="-120"/>
               </a:rPr>
-              <a:t>Each checked work type keeps its own gallery of site photos — click through to open full size.</a:t>
+              <a:t>Project, a description of what's needed, drawing type (Architectural / Structural / MEP / Civil…), and requester name.</a:t>
             </a:r>
             <a:endParaRPr lang="en-US" sz="1150" dirty="0"/>
           </a:p>
@@ -8860,7 +7506,7 @@
             <a:avLst/>
           </a:prstGeom>
           <a:solidFill>
-            <a:srgbClr val="4F46E5"/>
+            <a:srgbClr val="7C3AED"/>
           </a:solidFill>
           <a:ln/>
         </p:spPr>
@@ -8898,7 +7544,7 @@
                 <a:ea typeface="Segoe UI" pitchFamily="34" charset="-122"/>
                 <a:cs typeface="Segoe UI" pitchFamily="34" charset="-120"/>
               </a:rPr>
-              <a:t>A permanent, auditable record</a:t>
+              <a:t>Auto-numbered on submit</a:t>
             </a:r>
             <a:endParaRPr lang="en-US" sz="1450" dirty="0"/>
           </a:p>
@@ -8940,7 +7586,108 @@
                 <a:ea typeface="Segoe UI" pitchFamily="34" charset="-122"/>
                 <a:cs typeface="Segoe UI" pitchFamily="34" charset="-120"/>
               </a:rPr>
-              <a:t>Once submitted, the report and its photos become part of that project's history.</a:t>
+              <a:t>Every request gets its own ticket number (e.g. DR-0003) the moment it's raised.</a:t>
+            </a:r>
+            <a:endParaRPr lang="en-US" sz="1150" dirty="0"/>
+          </a:p>
+        </p:txBody>
+      </p:sp>
+      <p:sp>
+        <p:nvSpPr>
+          <p:cNvPr id="15" name="Shape 13"/>
+          <p:cNvSpPr/>
+          <p:nvPr/>
+        </p:nvSpPr>
+        <p:spPr>
+          <a:xfrm>
+            <a:off x="640080" y="4617720"/>
+            <a:ext cx="82296" cy="82296"/>
+          </a:xfrm>
+          <a:prstGeom prst="rect">
+            <a:avLst/>
+          </a:prstGeom>
+          <a:solidFill>
+            <a:srgbClr val="7C3AED"/>
+          </a:solidFill>
+          <a:ln/>
+        </p:spPr>
+      </p:sp>
+      <p:sp>
+        <p:nvSpPr>
+          <p:cNvPr id="16" name="Text 14"/>
+          <p:cNvSpPr/>
+          <p:nvPr/>
+        </p:nvSpPr>
+        <p:spPr>
+          <a:xfrm>
+            <a:off x="896112" y="4480560"/>
+            <a:ext cx="4773168" cy="292608"/>
+          </a:xfrm>
+          <a:prstGeom prst="rect">
+            <a:avLst/>
+          </a:prstGeom>
+          <a:noFill/>
+          <a:ln/>
+        </p:spPr>
+        <p:txBody>
+          <a:bodyPr wrap="square" rtlCol="0" anchor="ctr"/>
+          <a:lstStyle/>
+          <a:p>
+            <a:pPr indent="0" marL="0">
+              <a:buNone/>
+            </a:pPr>
+            <a:r>
+              <a:rPr lang="en-US" sz="1450" b="1" dirty="0">
+                <a:solidFill>
+                  <a:srgbClr val="1A1A2E"/>
+                </a:solidFill>
+                <a:latin typeface="Segoe UI" pitchFamily="34" charset="0"/>
+                <a:ea typeface="Segoe UI" pitchFamily="34" charset="-122"/>
+                <a:cs typeface="Segoe UI" pitchFamily="34" charset="-120"/>
+              </a:rPr>
+              <a:t>Also available publicly</a:t>
+            </a:r>
+            <a:endParaRPr lang="en-US" sz="1450" dirty="0"/>
+          </a:p>
+        </p:txBody>
+      </p:sp>
+      <p:sp>
+        <p:nvSpPr>
+          <p:cNvPr id="17" name="Text 15"/>
+          <p:cNvSpPr/>
+          <p:nvPr/>
+        </p:nvSpPr>
+        <p:spPr>
+          <a:xfrm>
+            <a:off x="896112" y="4773168"/>
+            <a:ext cx="4773168" cy="566928"/>
+          </a:xfrm>
+          <a:prstGeom prst="rect">
+            <a:avLst/>
+          </a:prstGeom>
+          <a:noFill/>
+          <a:ln/>
+        </p:spPr>
+        <p:txBody>
+          <a:bodyPr wrap="square" rtlCol="0" anchor="ctr"/>
+          <a:lstStyle/>
+          <a:p>
+            <a:pPr indent="0" marL="0">
+              <a:lnSpc>
+                <a:spcPct val="115000"/>
+              </a:lnSpc>
+              <a:buNone/>
+            </a:pPr>
+            <a:r>
+              <a:rPr lang="en-US" sz="1150" dirty="0">
+                <a:solidFill>
+                  <a:srgbClr val="475569"/>
+                </a:solidFill>
+                <a:latin typeface="Segoe UI" pitchFamily="34" charset="0"/>
+                <a:ea typeface="Segoe UI" pitchFamily="34" charset="-122"/>
+                <a:cs typeface="Segoe UI" pitchFamily="34" charset="-120"/>
+              </a:rPr>
+              <a:t>A standalone no-login form covers anyone on site without an account.</a:t>
             </a:r>
             <a:endParaRPr lang="en-US" sz="1150" dirty="0"/>
           </a:p>
@@ -8948,7 +7695,7 @@
       </p:sp>
       <p:pic>
         <p:nvPicPr>
-          <p:cNvPr id="15" name="Image 0" descr="shots/10_dpr_view_detail.png">    </p:cNvPr>
+          <p:cNvPr id="18" name="Image 0" descr="shots/12_drawing_request_filled.png">    </p:cNvPr>
           <p:cNvPicPr>
             <a:picLocks noChangeAspect="1"/>
           </p:cNvPicPr>
@@ -8979,7 +7726,7 @@
       </p:pic>
       <p:sp>
         <p:nvSpPr>
-          <p:cNvPr id="16" name="Text 13"/>
+          <p:cNvPr id="19" name="Text 16"/>
           <p:cNvSpPr/>
           <p:nvPr/>
         </p:nvSpPr>
@@ -9018,7 +7765,7 @@
       </p:sp>
       <p:sp>
         <p:nvSpPr>
-          <p:cNvPr id="17" name="Text 14"/>
+          <p:cNvPr id="20" name="Text 17"/>
           <p:cNvSpPr/>
           <p:nvPr/>
         </p:nvSpPr>
@@ -9049,7 +7796,7 @@
                 <a:ea typeface="Segoe UI" pitchFamily="34" charset="-122"/>
                 <a:cs typeface="Segoe UI" pitchFamily="34" charset="-120"/>
               </a:rPr>
-              <a:t>9</a:t>
+              <a:t>7</a:t>
             </a:r>
             <a:endParaRPr lang="en-US" sz="900" dirty="0"/>
           </a:p>

</xml_diff>